<commit_message>
feat & docs: implement table of contents shortcodes (part-deck, chapter-list, summary-bar) and update showcase
</commit_message>
<xml_diff>
--- a/public/showcase/showcase.pptx
+++ b/public/showcase/showcase.pptx
@@ -29,9 +29,12 @@
     <p:sldId id="277" r:id="rId23"/>
     <p:sldId id="278" r:id="rId24"/>
     <p:sldId id="279" r:id="rId25"/>
+    <p:sldId id="280" r:id="rId26"/>
+    <p:sldId id="281" r:id="rId27"/>
+    <p:sldId id="282" r:id="rId28"/>
   </p:sldIdLst>
   <p:notesMasterIdLst>
-    <p:notesMasterId r:id="rId26"/>
+    <p:notesMasterId r:id="rId29"/>
   </p:notesMasterIdLst>
   <p:sldSz cx="12192000" cy="6858000"/>
   <p:notesSz cx="6858000" cy="12192000"/>
@@ -1957,6 +1960,270 @@
             <a:fld id="{F7021451-1387-4CA6-816F-3879F97B5CBC}" type="slidenum">
               <a:rPr lang="en-US"/>
               <a:t>24</a:t>
+            </a:fld>
+            <a:endParaRPr lang="en-US"/>
+          </a:p>
+        </p:txBody>
+      </p:sp>
+    </p:spTree>
+    <p:extLst>
+      <p:ext uri="{BB962C8B-B14F-4D97-AF65-F5344CB8AC3E}">
+        <p14:creationId xmlns:p14="http://schemas.microsoft.com/office/powerpoint/2010/main" val="1024086991"/>
+      </p:ext>
+    </p:extLst>
+  </p:cSld>
+  <p:clrMapOvr>
+    <a:masterClrMapping/>
+  </p:clrMapOvr>
+</p:notes>
+</file>
+
+<file path=ppt/notesSlides/notesSlide25.xml><?xml version="1.0" encoding="utf-8"?>
+<p:notes xmlns:a="http://schemas.openxmlformats.org/drawingml/2006/main" xmlns:r="http://schemas.openxmlformats.org/officeDocument/2006/relationships" xmlns:p="http://schemas.openxmlformats.org/presentationml/2006/main">
+  <p:cSld>
+    <p:spTree>
+      <p:nvGrpSpPr>
+        <p:cNvPr id="1" name=""/>
+        <p:cNvGrpSpPr/>
+        <p:nvPr/>
+      </p:nvGrpSpPr>
+      <p:grpSpPr>
+        <a:xfrm>
+          <a:off x="0" y="0"/>
+          <a:ext cx="0" cy="0"/>
+          <a:chOff x="0" y="0"/>
+          <a:chExt cx="0" cy="0"/>
+        </a:xfrm>
+      </p:grpSpPr>
+      <p:sp>
+        <p:nvSpPr>
+          <p:cNvPr id="2" name="Slide Image Placeholder 1"/>
+          <p:cNvSpPr>
+            <a:spLocks noGrp="1" noRot="1" noChangeAspect="1"/>
+          </p:cNvSpPr>
+          <p:nvPr>
+            <p:ph type="sldImg"/>
+          </p:nvPr>
+        </p:nvSpPr>
+        <p:spPr/>
+      </p:sp>
+      <p:sp>
+        <p:nvSpPr>
+          <p:cNvPr id="3" name="Notes Placeholder 2"/>
+          <p:cNvSpPr>
+            <a:spLocks noGrp="1"/>
+          </p:cNvSpPr>
+          <p:nvPr>
+            <p:ph type="body" idx="1"/>
+          </p:nvPr>
+        </p:nvSpPr>
+        <p:spPr/>
+        <p:txBody>
+          <a:bodyPr/>
+          <a:lstStyle/>
+          <a:p>
+            <a:r>
+              <a:rPr lang="en-US" dirty="0"/>
+              <a:t/>
+            </a:r>
+            <a:endParaRPr lang="en-US" dirty="0"/>
+          </a:p>
+        </p:txBody>
+      </p:sp>
+      <p:sp>
+        <p:nvSpPr>
+          <p:cNvPr id="4" name="Slide Number Placeholder 3"/>
+          <p:cNvSpPr>
+            <a:spLocks noGrp="1"/>
+          </p:cNvSpPr>
+          <p:nvPr>
+            <p:ph type="sldNum" sz="quarter" idx="10"/>
+          </p:nvPr>
+        </p:nvSpPr>
+        <p:spPr/>
+        <p:txBody>
+          <a:bodyPr/>
+          <a:lstStyle/>
+          <a:p>
+            <a:fld id="{F7021451-1387-4CA6-816F-3879F97B5CBC}" type="slidenum">
+              <a:rPr lang="en-US"/>
+              <a:t>25</a:t>
+            </a:fld>
+            <a:endParaRPr lang="en-US"/>
+          </a:p>
+        </p:txBody>
+      </p:sp>
+    </p:spTree>
+    <p:extLst>
+      <p:ext uri="{BB962C8B-B14F-4D97-AF65-F5344CB8AC3E}">
+        <p14:creationId xmlns:p14="http://schemas.microsoft.com/office/powerpoint/2010/main" val="1024086991"/>
+      </p:ext>
+    </p:extLst>
+  </p:cSld>
+  <p:clrMapOvr>
+    <a:masterClrMapping/>
+  </p:clrMapOvr>
+</p:notes>
+</file>
+
+<file path=ppt/notesSlides/notesSlide26.xml><?xml version="1.0" encoding="utf-8"?>
+<p:notes xmlns:a="http://schemas.openxmlformats.org/drawingml/2006/main" xmlns:r="http://schemas.openxmlformats.org/officeDocument/2006/relationships" xmlns:p="http://schemas.openxmlformats.org/presentationml/2006/main">
+  <p:cSld>
+    <p:spTree>
+      <p:nvGrpSpPr>
+        <p:cNvPr id="1" name=""/>
+        <p:cNvGrpSpPr/>
+        <p:nvPr/>
+      </p:nvGrpSpPr>
+      <p:grpSpPr>
+        <a:xfrm>
+          <a:off x="0" y="0"/>
+          <a:ext cx="0" cy="0"/>
+          <a:chOff x="0" y="0"/>
+          <a:chExt cx="0" cy="0"/>
+        </a:xfrm>
+      </p:grpSpPr>
+      <p:sp>
+        <p:nvSpPr>
+          <p:cNvPr id="2" name="Slide Image Placeholder 1"/>
+          <p:cNvSpPr>
+            <a:spLocks noGrp="1" noRot="1" noChangeAspect="1"/>
+          </p:cNvSpPr>
+          <p:nvPr>
+            <p:ph type="sldImg"/>
+          </p:nvPr>
+        </p:nvSpPr>
+        <p:spPr/>
+      </p:sp>
+      <p:sp>
+        <p:nvSpPr>
+          <p:cNvPr id="3" name="Notes Placeholder 2"/>
+          <p:cNvSpPr>
+            <a:spLocks noGrp="1"/>
+          </p:cNvSpPr>
+          <p:nvPr>
+            <p:ph type="body" idx="1"/>
+          </p:nvPr>
+        </p:nvSpPr>
+        <p:spPr/>
+        <p:txBody>
+          <a:bodyPr/>
+          <a:lstStyle/>
+          <a:p>
+            <a:r>
+              <a:rPr lang="en-US" dirty="0"/>
+              <a:t/>
+            </a:r>
+            <a:endParaRPr lang="en-US" dirty="0"/>
+          </a:p>
+        </p:txBody>
+      </p:sp>
+      <p:sp>
+        <p:nvSpPr>
+          <p:cNvPr id="4" name="Slide Number Placeholder 3"/>
+          <p:cNvSpPr>
+            <a:spLocks noGrp="1"/>
+          </p:cNvSpPr>
+          <p:nvPr>
+            <p:ph type="sldNum" sz="quarter" idx="10"/>
+          </p:nvPr>
+        </p:nvSpPr>
+        <p:spPr/>
+        <p:txBody>
+          <a:bodyPr/>
+          <a:lstStyle/>
+          <a:p>
+            <a:fld id="{F7021451-1387-4CA6-816F-3879F97B5CBC}" type="slidenum">
+              <a:rPr lang="en-US"/>
+              <a:t>26</a:t>
+            </a:fld>
+            <a:endParaRPr lang="en-US"/>
+          </a:p>
+        </p:txBody>
+      </p:sp>
+    </p:spTree>
+    <p:extLst>
+      <p:ext uri="{BB962C8B-B14F-4D97-AF65-F5344CB8AC3E}">
+        <p14:creationId xmlns:p14="http://schemas.microsoft.com/office/powerpoint/2010/main" val="1024086991"/>
+      </p:ext>
+    </p:extLst>
+  </p:cSld>
+  <p:clrMapOvr>
+    <a:masterClrMapping/>
+  </p:clrMapOvr>
+</p:notes>
+</file>
+
+<file path=ppt/notesSlides/notesSlide27.xml><?xml version="1.0" encoding="utf-8"?>
+<p:notes xmlns:a="http://schemas.openxmlformats.org/drawingml/2006/main" xmlns:r="http://schemas.openxmlformats.org/officeDocument/2006/relationships" xmlns:p="http://schemas.openxmlformats.org/presentationml/2006/main">
+  <p:cSld>
+    <p:spTree>
+      <p:nvGrpSpPr>
+        <p:cNvPr id="1" name=""/>
+        <p:cNvGrpSpPr/>
+        <p:nvPr/>
+      </p:nvGrpSpPr>
+      <p:grpSpPr>
+        <a:xfrm>
+          <a:off x="0" y="0"/>
+          <a:ext cx="0" cy="0"/>
+          <a:chOff x="0" y="0"/>
+          <a:chExt cx="0" cy="0"/>
+        </a:xfrm>
+      </p:grpSpPr>
+      <p:sp>
+        <p:nvSpPr>
+          <p:cNvPr id="2" name="Slide Image Placeholder 1"/>
+          <p:cNvSpPr>
+            <a:spLocks noGrp="1" noRot="1" noChangeAspect="1"/>
+          </p:cNvSpPr>
+          <p:nvPr>
+            <p:ph type="sldImg"/>
+          </p:nvPr>
+        </p:nvSpPr>
+        <p:spPr/>
+      </p:sp>
+      <p:sp>
+        <p:nvSpPr>
+          <p:cNvPr id="3" name="Notes Placeholder 2"/>
+          <p:cNvSpPr>
+            <a:spLocks noGrp="1"/>
+          </p:cNvSpPr>
+          <p:nvPr>
+            <p:ph type="body" idx="1"/>
+          </p:nvPr>
+        </p:nvSpPr>
+        <p:spPr/>
+        <p:txBody>
+          <a:bodyPr/>
+          <a:lstStyle/>
+          <a:p>
+            <a:r>
+              <a:rPr lang="en-US" dirty="0"/>
+              <a:t/>
+            </a:r>
+            <a:endParaRPr lang="en-US" dirty="0"/>
+          </a:p>
+        </p:txBody>
+      </p:sp>
+      <p:sp>
+        <p:nvSpPr>
+          <p:cNvPr id="4" name="Slide Number Placeholder 3"/>
+          <p:cNvSpPr>
+            <a:spLocks noGrp="1"/>
+          </p:cNvSpPr>
+          <p:nvPr>
+            <p:ph type="sldNum" sz="quarter" idx="10"/>
+          </p:nvPr>
+        </p:nvSpPr>
+        <p:spPr/>
+        <p:txBody>
+          <a:bodyPr/>
+          <a:lstStyle/>
+          <a:p>
+            <a:fld id="{F7021451-1387-4CA6-816F-3879F97B5CBC}" type="slidenum">
+              <a:rPr lang="en-US"/>
+              <a:t>27</a:t>
             </a:fld>
             <a:endParaRPr lang="en-US"/>
           </a:p>
@@ -3058,7 +3325,7 @@
                 <a:ea typeface="Malgun Gothic" pitchFamily="34" charset="-122"/>
                 <a:cs typeface="Malgun Gothic" pitchFamily="34" charset="-120"/>
               </a:rPr>
-              <a:t>21종</a:t>
+              <a:t>24종</a:t>
             </a:r>
             <a:endParaRPr lang="en-US" sz="1800" dirty="0"/>
           </a:p>
@@ -23432,6 +23699,2705 @@
               <a:t>shortcode</a:t>
             </a:r>
             <a:endParaRPr lang="en-US" sz="800" dirty="0"/>
+          </a:p>
+        </p:txBody>
+      </p:sp>
+    </p:spTree>
+  </p:cSld>
+  <p:clrMapOvr>
+    <a:masterClrMapping/>
+  </p:clrMapOvr>
+</p:sld>
+</file>
+
+<file path=ppt/slides/slide25.xml><?xml version="1.0" encoding="utf-8"?>
+<p:sld xmlns:a="http://schemas.openxmlformats.org/drawingml/2006/main" xmlns:r="http://schemas.openxmlformats.org/officeDocument/2006/relationships" xmlns:p="http://schemas.openxmlformats.org/presentationml/2006/main">
+  <p:cSld name="Slide 25">
+    <p:bg>
+      <p:bgPr>
+        <a:solidFill>
+          <a:srgbClr val="FFFFFF"/>
+        </a:solidFill>
+      </p:bgPr>
+    </p:bg>
+    <p:spTree>
+      <p:nvGrpSpPr>
+        <p:cNvPr id="1" name=""/>
+        <p:cNvGrpSpPr/>
+        <p:nvPr/>
+      </p:nvGrpSpPr>
+      <p:grpSpPr>
+        <a:xfrm>
+          <a:off x="0" y="0"/>
+          <a:ext cx="0" cy="0"/>
+          <a:chOff x="0" y="0"/>
+          <a:chExt cx="0" cy="0"/>
+        </a:xfrm>
+      </p:grpSpPr>
+      <p:sp>
+        <p:nvSpPr>
+          <p:cNvPr id="2" name="Shape 0"/>
+          <p:cNvSpPr/>
+          <p:nvPr/>
+        </p:nvSpPr>
+        <p:spPr>
+          <a:xfrm>
+            <a:off x="0" y="0"/>
+            <a:ext cx="12191695" cy="960120"/>
+          </a:xfrm>
+          <a:prstGeom prst="rect">
+            <a:avLst/>
+          </a:prstGeom>
+          <a:solidFill>
+            <a:srgbClr val="0F172A"/>
+          </a:solidFill>
+          <a:ln w="12700">
+            <a:solidFill>
+              <a:srgbClr val="0F172A"/>
+            </a:solidFill>
+            <a:prstDash val="solid"/>
+          </a:ln>
+        </p:spPr>
+      </p:sp>
+      <p:sp>
+        <p:nvSpPr>
+          <p:cNvPr id="3" name="Shape 1"/>
+          <p:cNvSpPr/>
+          <p:nvPr/>
+        </p:nvSpPr>
+        <p:spPr>
+          <a:xfrm>
+            <a:off x="502920" y="228600"/>
+            <a:ext cx="502920" cy="502920"/>
+          </a:xfrm>
+          <a:prstGeom prst="roundRect">
+            <a:avLst>
+              <a:gd name="adj" fmla="val 18182"/>
+            </a:avLst>
+          </a:prstGeom>
+          <a:solidFill>
+            <a:srgbClr val="10A37F"/>
+          </a:solidFill>
+          <a:ln w="12700">
+            <a:solidFill>
+              <a:srgbClr val="10A37F"/>
+            </a:solidFill>
+            <a:prstDash val="solid"/>
+          </a:ln>
+        </p:spPr>
+      </p:sp>
+      <p:sp>
+        <p:nvSpPr>
+          <p:cNvPr id="4" name="Text 2"/>
+          <p:cNvSpPr/>
+          <p:nvPr/>
+        </p:nvSpPr>
+        <p:spPr>
+          <a:xfrm>
+            <a:off x="502920" y="228600"/>
+            <a:ext cx="502920" cy="502920"/>
+          </a:xfrm>
+          <a:prstGeom prst="rect">
+            <a:avLst/>
+          </a:prstGeom>
+          <a:noFill/>
+          <a:ln/>
+        </p:spPr>
+        <p:txBody>
+          <a:bodyPr wrap="square" rtlCol="0" anchor="ctr"/>
+          <a:lstStyle/>
+          <a:p>
+            <a:pPr algn="ctr" indent="0" marL="0">
+              <a:buNone/>
+            </a:pPr>
+            <a:r>
+              <a:rPr lang="en-US" sz="1600" b="1" dirty="0">
+                <a:solidFill>
+                  <a:srgbClr val="FFFFFF"/>
+                </a:solidFill>
+                <a:latin typeface="Malgun Gothic" pitchFamily="34" charset="0"/>
+                <a:ea typeface="Malgun Gothic" pitchFamily="34" charset="-122"/>
+                <a:cs typeface="Malgun Gothic" pitchFamily="34" charset="-120"/>
+              </a:rPr>
+              <a:t>22</a:t>
+            </a:r>
+            <a:endParaRPr lang="en-US" sz="1600" dirty="0"/>
+          </a:p>
+        </p:txBody>
+      </p:sp>
+      <p:sp>
+        <p:nvSpPr>
+          <p:cNvPr id="5" name="Text 3"/>
+          <p:cNvSpPr/>
+          <p:nvPr/>
+        </p:nvSpPr>
+        <p:spPr>
+          <a:xfrm>
+            <a:off x="1143000" y="0"/>
+            <a:ext cx="10957255" cy="960120"/>
+          </a:xfrm>
+          <a:prstGeom prst="rect">
+            <a:avLst/>
+          </a:prstGeom>
+          <a:noFill/>
+          <a:ln/>
+        </p:spPr>
+        <p:txBody>
+          <a:bodyPr wrap="square" rtlCol="0" anchor="ctr"/>
+          <a:lstStyle/>
+          <a:p>
+            <a:pPr indent="0" marL="0">
+              <a:buNone/>
+            </a:pPr>
+            <a:r>
+              <a:rPr lang="en-US" sz="2200" b="1" dirty="0">
+                <a:solidFill>
+                  <a:srgbClr val="FFFFFF"/>
+                </a:solidFill>
+                <a:latin typeface="Malgun Gothic" pitchFamily="34" charset="0"/>
+                <a:ea typeface="Malgun Gothic" pitchFamily="34" charset="-122"/>
+                <a:cs typeface="Malgun Gothic" pitchFamily="34" charset="-120"/>
+              </a:rPr>
+              <a:t>part-deck</a:t>
+            </a:r>
+            <a:endParaRPr lang="en-US" sz="2200" dirty="0"/>
+          </a:p>
+        </p:txBody>
+      </p:sp>
+      <p:sp>
+        <p:nvSpPr>
+          <p:cNvPr id="6" name="Shape 4"/>
+          <p:cNvSpPr/>
+          <p:nvPr/>
+        </p:nvSpPr>
+        <p:spPr>
+          <a:xfrm>
+            <a:off x="457200" y="1143000"/>
+            <a:ext cx="11277295" cy="4620514"/>
+          </a:xfrm>
+          <a:prstGeom prst="roundRect">
+            <a:avLst>
+              <a:gd name="adj" fmla="val 1583"/>
+            </a:avLst>
+          </a:prstGeom>
+          <a:solidFill>
+            <a:srgbClr val="FFFFFF"/>
+          </a:solidFill>
+          <a:ln w="9525">
+            <a:solidFill>
+              <a:srgbClr val="C8E6DF"/>
+            </a:solidFill>
+            <a:prstDash val="solid"/>
+          </a:ln>
+        </p:spPr>
+      </p:sp>
+      <p:graphicFrame>
+        <p:nvGraphicFramePr>
+          <p:cNvPr id="26" name="Table 0"/>
+          <p:cNvGraphicFramePr>
+            <a:graphicFrameLocks noGrp="1"/>
+          </p:cNvGraphicFramePr>
+          <p:nvPr>
+            <p:extLst>
+              <p:ext uri="{D42A27DB-BD31-4B8C-83A1-F6EECF244321}">
+                <p14:modId xmlns:p14="http://schemas.microsoft.com/office/powerpoint/2010/main" val="1579011935"/>
+              </p:ext>
+            </p:extLst>
+          </p:nvPr>
+        </p:nvGraphicFramePr>
+        <p:xfrm>
+          <a:off x="685800" y="1325880"/>
+          <a:ext cx="10820095" cy="914400"/>
+        </p:xfrm>
+        <a:graphic>
+          <a:graphicData uri="http://schemas.openxmlformats.org/drawingml/2006/table">
+            <a:tbl>
+              <a:tblPr/>
+              <a:tblGrid>
+                <a:gridCol w="5410048"/>
+                <a:gridCol w="5410048"/>
+              </a:tblGrid>
+              <a:tr h="320040">
+                <a:tc>
+                  <a:txBody>
+                    <a:bodyPr/>
+                    <a:lstStyle/>
+                    <a:p>
+                      <a:pPr indent="0" marL="0">
+                        <a:buNone/>
+                      </a:pPr>
+                      <a:r>
+                        <a:rPr lang="en-US" sz="1100" b="1" dirty="0">
+                          <a:solidFill>
+                            <a:srgbClr val="FFFFFF"/>
+                          </a:solidFill>
+                          <a:latin typeface="Malgun Gothic" pitchFamily="34" charset="0"/>
+                          <a:ea typeface="Malgun Gothic" pitchFamily="34" charset="-122"/>
+                          <a:cs typeface="Malgun Gothic" pitchFamily="34" charset="-120"/>
+                        </a:rPr>
+                        <a:t>항목</a:t>
+                      </a:r>
+                      <a:endParaRPr lang="en-US" sz="1100" dirty="0">
+                        <a:latin typeface="Malgun Gothic" charset="0"/>
+                        <a:ea typeface="Malgun Gothic" charset="0"/>
+                        <a:cs typeface="Malgun Gothic" charset="0"/>
+                      </a:endParaRPr>
+                    </a:p>
+                  </a:txBody>
+                  <a:tcPr marL="91440" marR="91440" marT="45720" marB="45720">
+                    <a:lnL w="12700" cap="flat" cmpd="sng" algn="ctr">
+                      <a:solidFill>
+                        <a:srgbClr val="C8E6DF"/>
+                      </a:solidFill>
+                      <a:prstDash val="solid"/>
+                      <a:round/>
+                      <a:headEnd type="none" w="med" len="med"/>
+                      <a:tailEnd type="none" w="med" len="med"/>
+                    </a:lnL>
+                    <a:lnR w="12700" cap="flat" cmpd="sng" algn="ctr">
+                      <a:solidFill>
+                        <a:srgbClr val="C8E6DF"/>
+                      </a:solidFill>
+                      <a:prstDash val="solid"/>
+                      <a:round/>
+                      <a:headEnd type="none" w="med" len="med"/>
+                      <a:tailEnd type="none" w="med" len="med"/>
+                    </a:lnR>
+                    <a:lnT w="12700" cap="flat" cmpd="sng" algn="ctr">
+                      <a:solidFill>
+                        <a:srgbClr val="C8E6DF"/>
+                      </a:solidFill>
+                      <a:prstDash val="solid"/>
+                      <a:round/>
+                      <a:headEnd type="none" w="med" len="med"/>
+                      <a:tailEnd type="none" w="med" len="med"/>
+                    </a:lnT>
+                    <a:lnB w="12700" cap="flat" cmpd="sng" algn="ctr">
+                      <a:solidFill>
+                        <a:srgbClr val="C8E6DF"/>
+                      </a:solidFill>
+                      <a:prstDash val="solid"/>
+                      <a:round/>
+                      <a:headEnd type="none" w="med" len="med"/>
+                      <a:tailEnd type="none" w="med" len="med"/>
+                    </a:lnB>
+                    <a:solidFill>
+                      <a:srgbClr val="10A37F"/>
+                    </a:solidFill>
+                  </a:tcPr>
+                </a:tc>
+                <a:tc>
+                  <a:txBody>
+                    <a:bodyPr/>
+                    <a:lstStyle/>
+                    <a:p>
+                      <a:pPr indent="0" marL="0">
+                        <a:buNone/>
+                      </a:pPr>
+                      <a:r>
+                        <a:rPr lang="en-US" sz="1100" b="1" dirty="0">
+                          <a:solidFill>
+                            <a:srgbClr val="FFFFFF"/>
+                          </a:solidFill>
+                          <a:latin typeface="Malgun Gothic" pitchFamily="34" charset="0"/>
+                          <a:ea typeface="Malgun Gothic" pitchFamily="34" charset="-122"/>
+                          <a:cs typeface="Malgun Gothic" pitchFamily="34" charset="-120"/>
+                        </a:rPr>
+                        <a:t>내용</a:t>
+                      </a:r>
+                      <a:endParaRPr lang="en-US" sz="1100" dirty="0">
+                        <a:latin typeface="Malgun Gothic" charset="0"/>
+                        <a:ea typeface="Malgun Gothic" charset="0"/>
+                        <a:cs typeface="Malgun Gothic" charset="0"/>
+                      </a:endParaRPr>
+                    </a:p>
+                  </a:txBody>
+                  <a:tcPr marL="91440" marR="91440" marT="45720" marB="45720">
+                    <a:lnL w="12700" cap="flat" cmpd="sng" algn="ctr">
+                      <a:solidFill>
+                        <a:srgbClr val="C8E6DF"/>
+                      </a:solidFill>
+                      <a:prstDash val="solid"/>
+                      <a:round/>
+                      <a:headEnd type="none" w="med" len="med"/>
+                      <a:tailEnd type="none" w="med" len="med"/>
+                    </a:lnL>
+                    <a:lnR w="12700" cap="flat" cmpd="sng" algn="ctr">
+                      <a:solidFill>
+                        <a:srgbClr val="C8E6DF"/>
+                      </a:solidFill>
+                      <a:prstDash val="solid"/>
+                      <a:round/>
+                      <a:headEnd type="none" w="med" len="med"/>
+                      <a:tailEnd type="none" w="med" len="med"/>
+                    </a:lnR>
+                    <a:lnT w="12700" cap="flat" cmpd="sng" algn="ctr">
+                      <a:solidFill>
+                        <a:srgbClr val="C8E6DF"/>
+                      </a:solidFill>
+                      <a:prstDash val="solid"/>
+                      <a:round/>
+                      <a:headEnd type="none" w="med" len="med"/>
+                      <a:tailEnd type="none" w="med" len="med"/>
+                    </a:lnT>
+                    <a:lnB w="12700" cap="flat" cmpd="sng" algn="ctr">
+                      <a:solidFill>
+                        <a:srgbClr val="C8E6DF"/>
+                      </a:solidFill>
+                      <a:prstDash val="solid"/>
+                      <a:round/>
+                      <a:headEnd type="none" w="med" len="med"/>
+                      <a:tailEnd type="none" w="med" len="med"/>
+                    </a:lnB>
+                    <a:solidFill>
+                      <a:srgbClr val="10A37F"/>
+                    </a:solidFill>
+                  </a:tcPr>
+                </a:tc>
+              </a:tr>
+              <a:tr h="256032">
+                <a:tc>
+                  <a:txBody>
+                    <a:bodyPr/>
+                    <a:lstStyle/>
+                    <a:p>
+                      <a:pPr indent="0" marL="0">
+                        <a:buNone/>
+                      </a:pPr>
+                      <a:r>
+                        <a:rPr lang="en-US" sz="1000" dirty="0">
+                          <a:solidFill>
+                            <a:srgbClr val="475569"/>
+                          </a:solidFill>
+                          <a:latin typeface="Malgun Gothic" pitchFamily="34" charset="0"/>
+                          <a:ea typeface="Malgun Gothic" pitchFamily="34" charset="-122"/>
+                          <a:cs typeface="Malgun Gothic" pitchFamily="34" charset="-120"/>
+                        </a:rPr>
+                        <a:t>숏코드 명</a:t>
+                      </a:r>
+                      <a:endParaRPr lang="en-US" sz="1000" dirty="0">
+                        <a:latin typeface="Malgun Gothic" charset="0"/>
+                        <a:ea typeface="Malgun Gothic" charset="0"/>
+                        <a:cs typeface="Malgun Gothic" charset="0"/>
+                      </a:endParaRPr>
+                    </a:p>
+                  </a:txBody>
+                  <a:tcPr marL="91440" marR="91440" marT="45720" marB="45720">
+                    <a:lnL w="12700" cap="flat" cmpd="sng" algn="ctr">
+                      <a:solidFill>
+                        <a:srgbClr val="C8E6DF"/>
+                      </a:solidFill>
+                      <a:prstDash val="solid"/>
+                      <a:round/>
+                      <a:headEnd type="none" w="med" len="med"/>
+                      <a:tailEnd type="none" w="med" len="med"/>
+                    </a:lnL>
+                    <a:lnR w="12700" cap="flat" cmpd="sng" algn="ctr">
+                      <a:solidFill>
+                        <a:srgbClr val="C8E6DF"/>
+                      </a:solidFill>
+                      <a:prstDash val="solid"/>
+                      <a:round/>
+                      <a:headEnd type="none" w="med" len="med"/>
+                      <a:tailEnd type="none" w="med" len="med"/>
+                    </a:lnR>
+                    <a:lnT w="12700" cap="flat" cmpd="sng" algn="ctr">
+                      <a:solidFill>
+                        <a:srgbClr val="C8E6DF"/>
+                      </a:solidFill>
+                      <a:prstDash val="solid"/>
+                      <a:round/>
+                      <a:headEnd type="none" w="med" len="med"/>
+                      <a:tailEnd type="none" w="med" len="med"/>
+                    </a:lnT>
+                    <a:lnB w="12700" cap="flat" cmpd="sng" algn="ctr">
+                      <a:solidFill>
+                        <a:srgbClr val="C8E6DF"/>
+                      </a:solidFill>
+                      <a:prstDash val="solid"/>
+                      <a:round/>
+                      <a:headEnd type="none" w="med" len="med"/>
+                      <a:tailEnd type="none" w="med" len="med"/>
+                    </a:lnB>
+                  </a:tcPr>
+                </a:tc>
+                <a:tc>
+                  <a:txBody>
+                    <a:bodyPr/>
+                    <a:lstStyle/>
+                    <a:p>
+                      <a:pPr indent="0" marL="0">
+                        <a:buNone/>
+                      </a:pPr>
+                      <a:r>
+                        <a:rPr lang="en-US" sz="1000" dirty="0">
+                          <a:solidFill>
+                            <a:srgbClr val="475569"/>
+                          </a:solidFill>
+                          <a:latin typeface="Malgun Gothic" pitchFamily="34" charset="0"/>
+                          <a:ea typeface="Malgun Gothic" pitchFamily="34" charset="-122"/>
+                          <a:cs typeface="Malgun Gothic" pitchFamily="34" charset="-120"/>
+                        </a:rPr>
+                        <a:t>part-deck</a:t>
+                      </a:r>
+                      <a:endParaRPr lang="en-US" sz="1000" dirty="0">
+                        <a:latin typeface="Malgun Gothic" charset="0"/>
+                        <a:ea typeface="Malgun Gothic" charset="0"/>
+                        <a:cs typeface="Malgun Gothic" charset="0"/>
+                      </a:endParaRPr>
+                    </a:p>
+                  </a:txBody>
+                  <a:tcPr marL="91440" marR="91440" marT="45720" marB="45720">
+                    <a:lnL w="12700" cap="flat" cmpd="sng" algn="ctr">
+                      <a:solidFill>
+                        <a:srgbClr val="C8E6DF"/>
+                      </a:solidFill>
+                      <a:prstDash val="solid"/>
+                      <a:round/>
+                      <a:headEnd type="none" w="med" len="med"/>
+                      <a:tailEnd type="none" w="med" len="med"/>
+                    </a:lnL>
+                    <a:lnR w="12700" cap="flat" cmpd="sng" algn="ctr">
+                      <a:solidFill>
+                        <a:srgbClr val="C8E6DF"/>
+                      </a:solidFill>
+                      <a:prstDash val="solid"/>
+                      <a:round/>
+                      <a:headEnd type="none" w="med" len="med"/>
+                      <a:tailEnd type="none" w="med" len="med"/>
+                    </a:lnR>
+                    <a:lnT w="12700" cap="flat" cmpd="sng" algn="ctr">
+                      <a:solidFill>
+                        <a:srgbClr val="C8E6DF"/>
+                      </a:solidFill>
+                      <a:prstDash val="solid"/>
+                      <a:round/>
+                      <a:headEnd type="none" w="med" len="med"/>
+                      <a:tailEnd type="none" w="med" len="med"/>
+                    </a:lnT>
+                    <a:lnB w="12700" cap="flat" cmpd="sng" algn="ctr">
+                      <a:solidFill>
+                        <a:srgbClr val="C8E6DF"/>
+                      </a:solidFill>
+                      <a:prstDash val="solid"/>
+                      <a:round/>
+                      <a:headEnd type="none" w="med" len="med"/>
+                      <a:tailEnd type="none" w="med" len="med"/>
+                    </a:lnB>
+                  </a:tcPr>
+                </a:tc>
+              </a:tr>
+              <a:tr h="256032">
+                <a:tc>
+                  <a:txBody>
+                    <a:bodyPr/>
+                    <a:lstStyle/>
+                    <a:p>
+                      <a:pPr indent="0" marL="0">
+                        <a:buNone/>
+                      </a:pPr>
+                      <a:r>
+                        <a:rPr lang="en-US" sz="1000" dirty="0">
+                          <a:solidFill>
+                            <a:srgbClr val="475569"/>
+                          </a:solidFill>
+                          <a:latin typeface="Malgun Gothic" pitchFamily="34" charset="0"/>
+                          <a:ea typeface="Malgun Gothic" pitchFamily="34" charset="-122"/>
+                          <a:cs typeface="Malgun Gothic" pitchFamily="34" charset="-120"/>
+                        </a:rPr>
+                        <a:t>구현내용</a:t>
+                      </a:r>
+                      <a:endParaRPr lang="en-US" sz="1000" dirty="0">
+                        <a:latin typeface="Malgun Gothic" charset="0"/>
+                        <a:ea typeface="Malgun Gothic" charset="0"/>
+                        <a:cs typeface="Malgun Gothic" charset="0"/>
+                      </a:endParaRPr>
+                    </a:p>
+                  </a:txBody>
+                  <a:tcPr marL="91440" marR="91440" marT="45720" marB="45720">
+                    <a:lnL w="12700" cap="flat" cmpd="sng" algn="ctr">
+                      <a:solidFill>
+                        <a:srgbClr val="C8E6DF"/>
+                      </a:solidFill>
+                      <a:prstDash val="solid"/>
+                      <a:round/>
+                      <a:headEnd type="none" w="med" len="med"/>
+                      <a:tailEnd type="none" w="med" len="med"/>
+                    </a:lnL>
+                    <a:lnR w="12700" cap="flat" cmpd="sng" algn="ctr">
+                      <a:solidFill>
+                        <a:srgbClr val="C8E6DF"/>
+                      </a:solidFill>
+                      <a:prstDash val="solid"/>
+                      <a:round/>
+                      <a:headEnd type="none" w="med" len="med"/>
+                      <a:tailEnd type="none" w="med" len="med"/>
+                    </a:lnR>
+                    <a:lnT w="12700" cap="flat" cmpd="sng" algn="ctr">
+                      <a:solidFill>
+                        <a:srgbClr val="C8E6DF"/>
+                      </a:solidFill>
+                      <a:prstDash val="solid"/>
+                      <a:round/>
+                      <a:headEnd type="none" w="med" len="med"/>
+                      <a:tailEnd type="none" w="med" len="med"/>
+                    </a:lnT>
+                    <a:lnB w="12700" cap="flat" cmpd="sng" algn="ctr">
+                      <a:solidFill>
+                        <a:srgbClr val="C8E6DF"/>
+                      </a:solidFill>
+                      <a:prstDash val="solid"/>
+                      <a:round/>
+                      <a:headEnd type="none" w="med" len="med"/>
+                      <a:tailEnd type="none" w="med" len="med"/>
+                    </a:lnB>
+                  </a:tcPr>
+                </a:tc>
+                <a:tc>
+                  <a:txBody>
+                    <a:bodyPr/>
+                    <a:lstStyle/>
+                    <a:p>
+                      <a:pPr indent="0" marL="0">
+                        <a:buNone/>
+                      </a:pPr>
+                      <a:r>
+                        <a:rPr lang="en-US" sz="1000" dirty="0">
+                          <a:solidFill>
+                            <a:srgbClr val="475569"/>
+                          </a:solidFill>
+                          <a:latin typeface="Malgun Gothic" pitchFamily="34" charset="0"/>
+                          <a:ea typeface="Malgun Gothic" pitchFamily="34" charset="-122"/>
+                          <a:cs typeface="Malgun Gothic" pitchFamily="34" charset="-120"/>
+                        </a:rPr>
+                        <a:t>시리즈 가이드북 등 목차용 대단원(부, Part)을 알리는 헤더 숏코드입니다. HSL 브랜드 컬러가 다이내믹하게 적용됩니다.</a:t>
+                      </a:r>
+                      <a:endParaRPr lang="en-US" sz="1000" dirty="0">
+                        <a:latin typeface="Malgun Gothic" charset="0"/>
+                        <a:ea typeface="Malgun Gothic" charset="0"/>
+                        <a:cs typeface="Malgun Gothic" charset="0"/>
+                      </a:endParaRPr>
+                    </a:p>
+                  </a:txBody>
+                  <a:tcPr marL="91440" marR="91440" marT="45720" marB="45720">
+                    <a:lnL w="12700" cap="flat" cmpd="sng" algn="ctr">
+                      <a:solidFill>
+                        <a:srgbClr val="C8E6DF"/>
+                      </a:solidFill>
+                      <a:prstDash val="solid"/>
+                      <a:round/>
+                      <a:headEnd type="none" w="med" len="med"/>
+                      <a:tailEnd type="none" w="med" len="med"/>
+                    </a:lnL>
+                    <a:lnR w="12700" cap="flat" cmpd="sng" algn="ctr">
+                      <a:solidFill>
+                        <a:srgbClr val="C8E6DF"/>
+                      </a:solidFill>
+                      <a:prstDash val="solid"/>
+                      <a:round/>
+                      <a:headEnd type="none" w="med" len="med"/>
+                      <a:tailEnd type="none" w="med" len="med"/>
+                    </a:lnR>
+                    <a:lnT w="12700" cap="flat" cmpd="sng" algn="ctr">
+                      <a:solidFill>
+                        <a:srgbClr val="C8E6DF"/>
+                      </a:solidFill>
+                      <a:prstDash val="solid"/>
+                      <a:round/>
+                      <a:headEnd type="none" w="med" len="med"/>
+                      <a:tailEnd type="none" w="med" len="med"/>
+                    </a:lnT>
+                    <a:lnB w="12700" cap="flat" cmpd="sng" algn="ctr">
+                      <a:solidFill>
+                        <a:srgbClr val="C8E6DF"/>
+                      </a:solidFill>
+                      <a:prstDash val="solid"/>
+                      <a:round/>
+                      <a:headEnd type="none" w="med" len="med"/>
+                      <a:tailEnd type="none" w="med" len="med"/>
+                    </a:lnB>
+                  </a:tcPr>
+                </a:tc>
+              </a:tr>
+            </a:tbl>
+          </a:graphicData>
+        </a:graphic>
+      </p:graphicFrame>
+      <p:sp>
+        <p:nvSpPr>
+          <p:cNvPr id="8" name="Text 5"/>
+          <p:cNvSpPr/>
+          <p:nvPr/>
+        </p:nvSpPr>
+        <p:spPr>
+          <a:xfrm>
+            <a:off x="685800" y="2295144"/>
+            <a:ext cx="10820095" cy="237490"/>
+          </a:xfrm>
+          <a:prstGeom prst="rect">
+            <a:avLst/>
+          </a:prstGeom>
+          <a:noFill/>
+          <a:ln/>
+        </p:spPr>
+        <p:txBody>
+          <a:bodyPr wrap="square" rtlCol="0" anchor="t"/>
+          <a:lstStyle/>
+          <a:p>
+            <a:pPr indent="0" marL="0">
+              <a:buNone/>
+            </a:pPr>
+            <a:r>
+              <a:rPr lang="en-US" sz="1100" dirty="0">
+                <a:solidFill>
+                  <a:srgbClr val="475569"/>
+                </a:solidFill>
+                <a:latin typeface="Malgun Gothic" pitchFamily="34" charset="0"/>
+                <a:ea typeface="Malgun Gothic" pitchFamily="34" charset="-122"/>
+                <a:cs typeface="Malgun Gothic" pitchFamily="34" charset="-120"/>
+              </a:rPr>
+              <a:t>숏코드 입력내용</a:t>
+            </a:r>
+            <a:endParaRPr lang="en-US" sz="1100" dirty="0"/>
+          </a:p>
+        </p:txBody>
+      </p:sp>
+      <p:sp>
+        <p:nvSpPr>
+          <p:cNvPr id="9" name="Shape 6"/>
+          <p:cNvSpPr/>
+          <p:nvPr/>
+        </p:nvSpPr>
+        <p:spPr>
+          <a:xfrm>
+            <a:off x="685800" y="2669794"/>
+            <a:ext cx="10820095" cy="2773680"/>
+          </a:xfrm>
+          <a:prstGeom prst="rect">
+            <a:avLst/>
+          </a:prstGeom>
+          <a:solidFill>
+            <a:srgbClr val="0F172A"/>
+          </a:solidFill>
+          <a:ln w="9525">
+            <a:solidFill>
+              <a:srgbClr val="C8E6DF"/>
+            </a:solidFill>
+            <a:prstDash val="solid"/>
+          </a:ln>
+        </p:spPr>
+      </p:sp>
+      <p:sp>
+        <p:nvSpPr>
+          <p:cNvPr id="10" name="Text 7"/>
+          <p:cNvSpPr/>
+          <p:nvPr/>
+        </p:nvSpPr>
+        <p:spPr>
+          <a:xfrm>
+            <a:off x="795528" y="2742946"/>
+            <a:ext cx="10600639" cy="2682240"/>
+          </a:xfrm>
+          <a:prstGeom prst="rect">
+            <a:avLst/>
+          </a:prstGeom>
+          <a:noFill/>
+          <a:ln/>
+        </p:spPr>
+        <p:txBody>
+          <a:bodyPr wrap="square" rtlCol="0" anchor="t"/>
+          <a:lstStyle/>
+          <a:p>
+            <a:pPr indent="0" marL="0">
+              <a:buNone/>
+            </a:pPr>
+            <a:r>
+              <a:rPr lang="en-US" sz="1000" dirty="0">
+                <a:solidFill>
+                  <a:srgbClr val="A8B2D8"/>
+                </a:solidFill>
+                <a:latin typeface="Consolas" pitchFamily="34" charset="0"/>
+                <a:ea typeface="Consolas" pitchFamily="34" charset="-122"/>
+                <a:cs typeface="Consolas" pitchFamily="34" charset="-120"/>
+              </a:rPr>
+              <a:t>\::: part-deck</a:t>
+            </a:r>
+            <a:endParaRPr lang="en-US" sz="1000" dirty="0"/>
+          </a:p>
+          <a:p>
+            <a:pPr indent="0" marL="0">
+              <a:buNone/>
+            </a:pPr>
+            <a:r>
+              <a:rPr lang="en-US" sz="1000" dirty="0">
+                <a:solidFill>
+                  <a:srgbClr val="A8B2D8"/>
+                </a:solidFill>
+                <a:latin typeface="Consolas" pitchFamily="34" charset="0"/>
+                <a:ea typeface="Consolas" pitchFamily="34" charset="-122"/>
+                <a:cs typeface="Consolas" pitchFamily="34" charset="-120"/>
+              </a:rPr>
+              <a:t>- icon: "1부"</a:t>
+            </a:r>
+            <a:endParaRPr lang="en-US" sz="1000" dirty="0"/>
+          </a:p>
+          <a:p>
+            <a:pPr indent="0" marL="0">
+              <a:buNone/>
+            </a:pPr>
+            <a:r>
+              <a:rPr lang="en-US" sz="1000" dirty="0">
+                <a:solidFill>
+                  <a:srgbClr val="A8B2D8"/>
+                </a:solidFill>
+                <a:latin typeface="Consolas" pitchFamily="34" charset="0"/>
+                <a:ea typeface="Consolas" pitchFamily="34" charset="-122"/>
+                <a:cs typeface="Consolas" pitchFamily="34" charset="-120"/>
+              </a:rPr>
+              <a:t>  title: "개념 이해"</a:t>
+            </a:r>
+            <a:endParaRPr lang="en-US" sz="1000" dirty="0"/>
+          </a:p>
+          <a:p>
+            <a:pPr indent="0" marL="0">
+              <a:buNone/>
+            </a:pPr>
+            <a:r>
+              <a:rPr lang="en-US" sz="1000" dirty="0">
+                <a:solidFill>
+                  <a:srgbClr val="A8B2D8"/>
+                </a:solidFill>
+                <a:latin typeface="Consolas" pitchFamily="34" charset="0"/>
+                <a:ea typeface="Consolas" pitchFamily="34" charset="-122"/>
+                <a:cs typeface="Consolas" pitchFamily="34" charset="-120"/>
+              </a:rPr>
+              <a:t>  desc: "바이브코딩과 에이전트 코딩의 작동 원리"</a:t>
+            </a:r>
+            <a:endParaRPr lang="en-US" sz="1000" dirty="0"/>
+          </a:p>
+          <a:p>
+            <a:pPr indent="0" marL="0">
+              <a:buNone/>
+            </a:pPr>
+            <a:r>
+              <a:rPr lang="en-US" sz="1000" dirty="0">
+                <a:solidFill>
+                  <a:srgbClr val="A8B2D8"/>
+                </a:solidFill>
+                <a:latin typeface="Consolas" pitchFamily="34" charset="0"/>
+                <a:ea typeface="Consolas" pitchFamily="34" charset="-122"/>
+                <a:cs typeface="Consolas" pitchFamily="34" charset="-120"/>
+              </a:rPr>
+              <a:t>  tag: "Ch.01–03"</a:t>
+            </a:r>
+            <a:endParaRPr lang="en-US" sz="1000" dirty="0"/>
+          </a:p>
+          <a:p>
+            <a:pPr indent="0" marL="0">
+              <a:buNone/>
+            </a:pPr>
+            <a:r>
+              <a:rPr lang="en-US" sz="1000" dirty="0">
+                <a:solidFill>
+                  <a:srgbClr val="A8B2D8"/>
+                </a:solidFill>
+                <a:latin typeface="Consolas" pitchFamily="34" charset="0"/>
+                <a:ea typeface="Consolas" pitchFamily="34" charset="-122"/>
+                <a:cs typeface="Consolas" pitchFamily="34" charset="-120"/>
+              </a:rPr>
+              <a:t>  color: "#1a3a5c"</a:t>
+            </a:r>
+            <a:endParaRPr lang="en-US" sz="1000" dirty="0"/>
+          </a:p>
+          <a:p>
+            <a:pPr indent="0" marL="0">
+              <a:buNone/>
+            </a:pPr>
+            <a:r>
+              <a:rPr lang="en-US" sz="1000" dirty="0">
+                <a:solidFill>
+                  <a:srgbClr val="A8B2D8"/>
+                </a:solidFill>
+                <a:latin typeface="Consolas" pitchFamily="34" charset="0"/>
+                <a:ea typeface="Consolas" pitchFamily="34" charset="-122"/>
+                <a:cs typeface="Consolas" pitchFamily="34" charset="-120"/>
+              </a:rPr>
+              <a:t>- icon: "2부"</a:t>
+            </a:r>
+            <a:endParaRPr lang="en-US" sz="1000" dirty="0"/>
+          </a:p>
+          <a:p>
+            <a:pPr indent="0" marL="0">
+              <a:buNone/>
+            </a:pPr>
+            <a:r>
+              <a:rPr lang="en-US" sz="1000" dirty="0">
+                <a:solidFill>
+                  <a:srgbClr val="A8B2D8"/>
+                </a:solidFill>
+                <a:latin typeface="Consolas" pitchFamily="34" charset="0"/>
+                <a:ea typeface="Consolas" pitchFamily="34" charset="-122"/>
+                <a:cs typeface="Consolas" pitchFamily="34" charset="-120"/>
+              </a:rPr>
+              <a:t>  title: "AI와 대화하는 법"</a:t>
+            </a:r>
+            <a:endParaRPr lang="en-US" sz="1000" dirty="0"/>
+          </a:p>
+          <a:p>
+            <a:pPr indent="0" marL="0">
+              <a:buNone/>
+            </a:pPr>
+            <a:r>
+              <a:rPr lang="en-US" sz="1000" dirty="0">
+                <a:solidFill>
+                  <a:srgbClr val="A8B2D8"/>
+                </a:solidFill>
+                <a:latin typeface="Consolas" pitchFamily="34" charset="0"/>
+                <a:ea typeface="Consolas" pitchFamily="34" charset="-122"/>
+                <a:cs typeface="Consolas" pitchFamily="34" charset="-120"/>
+              </a:rPr>
+              <a:t>  desc: "프롬프트 설계부터 복잡한 작업 위임까지"</a:t>
+            </a:r>
+            <a:endParaRPr lang="en-US" sz="1000" dirty="0"/>
+          </a:p>
+          <a:p>
+            <a:pPr indent="0" marL="0">
+              <a:buNone/>
+            </a:pPr>
+            <a:r>
+              <a:rPr lang="en-US" sz="1000" dirty="0">
+                <a:solidFill>
+                  <a:srgbClr val="A8B2D8"/>
+                </a:solidFill>
+                <a:latin typeface="Consolas" pitchFamily="34" charset="0"/>
+                <a:ea typeface="Consolas" pitchFamily="34" charset="-122"/>
+                <a:cs typeface="Consolas" pitchFamily="34" charset="-120"/>
+              </a:rPr>
+              <a:t>  tag: "Ch.04–05"</a:t>
+            </a:r>
+            <a:endParaRPr lang="en-US" sz="1000" dirty="0"/>
+          </a:p>
+          <a:p>
+            <a:pPr indent="0" marL="0">
+              <a:buNone/>
+            </a:pPr>
+            <a:r>
+              <a:rPr lang="en-US" sz="1000" dirty="0">
+                <a:solidFill>
+                  <a:srgbClr val="A8B2D8"/>
+                </a:solidFill>
+                <a:latin typeface="Consolas" pitchFamily="34" charset="0"/>
+                <a:ea typeface="Consolas" pitchFamily="34" charset="-122"/>
+                <a:cs typeface="Consolas" pitchFamily="34" charset="-120"/>
+              </a:rPr>
+              <a:t>  color: "#1a4a3a"</a:t>
+            </a:r>
+            <a:endParaRPr lang="en-US" sz="1000" dirty="0"/>
+          </a:p>
+          <a:p>
+            <a:pPr indent="0" marL="0">
+              <a:buNone/>
+            </a:pPr>
+            <a:r>
+              <a:rPr lang="en-US" sz="1000" dirty="0">
+                <a:solidFill>
+                  <a:srgbClr val="A8B2D8"/>
+                </a:solidFill>
+                <a:latin typeface="Consolas" pitchFamily="34" charset="0"/>
+                <a:ea typeface="Consolas" pitchFamily="34" charset="-122"/>
+                <a:cs typeface="Consolas" pitchFamily="34" charset="-120"/>
+              </a:rPr>
+              <a:t>\:::</a:t>
+            </a:r>
+            <a:endParaRPr lang="en-US" sz="1000" dirty="0"/>
+          </a:p>
+        </p:txBody>
+      </p:sp>
+    </p:spTree>
+  </p:cSld>
+  <p:clrMapOvr>
+    <a:masterClrMapping/>
+  </p:clrMapOvr>
+</p:sld>
+</file>
+
+<file path=ppt/slides/slide26.xml><?xml version="1.0" encoding="utf-8"?>
+<p:sld xmlns:a="http://schemas.openxmlformats.org/drawingml/2006/main" xmlns:r="http://schemas.openxmlformats.org/officeDocument/2006/relationships" xmlns:p="http://schemas.openxmlformats.org/presentationml/2006/main">
+  <p:cSld name="Slide 26">
+    <p:bg>
+      <p:bgPr>
+        <a:solidFill>
+          <a:srgbClr val="FFFFFF"/>
+        </a:solidFill>
+      </p:bgPr>
+    </p:bg>
+    <p:spTree>
+      <p:nvGrpSpPr>
+        <p:cNvPr id="1" name=""/>
+        <p:cNvGrpSpPr/>
+        <p:nvPr/>
+      </p:nvGrpSpPr>
+      <p:grpSpPr>
+        <a:xfrm>
+          <a:off x="0" y="0"/>
+          <a:ext cx="0" cy="0"/>
+          <a:chOff x="0" y="0"/>
+          <a:chExt cx="0" cy="0"/>
+        </a:xfrm>
+      </p:grpSpPr>
+      <p:sp>
+        <p:nvSpPr>
+          <p:cNvPr id="2" name="Shape 0"/>
+          <p:cNvSpPr/>
+          <p:nvPr/>
+        </p:nvSpPr>
+        <p:spPr>
+          <a:xfrm>
+            <a:off x="0" y="0"/>
+            <a:ext cx="12191695" cy="960120"/>
+          </a:xfrm>
+          <a:prstGeom prst="rect">
+            <a:avLst/>
+          </a:prstGeom>
+          <a:solidFill>
+            <a:srgbClr val="0F172A"/>
+          </a:solidFill>
+          <a:ln w="12700">
+            <a:solidFill>
+              <a:srgbClr val="0F172A"/>
+            </a:solidFill>
+            <a:prstDash val="solid"/>
+          </a:ln>
+        </p:spPr>
+      </p:sp>
+      <p:sp>
+        <p:nvSpPr>
+          <p:cNvPr id="3" name="Shape 1"/>
+          <p:cNvSpPr/>
+          <p:nvPr/>
+        </p:nvSpPr>
+        <p:spPr>
+          <a:xfrm>
+            <a:off x="502920" y="228600"/>
+            <a:ext cx="502920" cy="502920"/>
+          </a:xfrm>
+          <a:prstGeom prst="roundRect">
+            <a:avLst>
+              <a:gd name="adj" fmla="val 18182"/>
+            </a:avLst>
+          </a:prstGeom>
+          <a:solidFill>
+            <a:srgbClr val="10A37F"/>
+          </a:solidFill>
+          <a:ln w="12700">
+            <a:solidFill>
+              <a:srgbClr val="10A37F"/>
+            </a:solidFill>
+            <a:prstDash val="solid"/>
+          </a:ln>
+        </p:spPr>
+      </p:sp>
+      <p:sp>
+        <p:nvSpPr>
+          <p:cNvPr id="4" name="Text 2"/>
+          <p:cNvSpPr/>
+          <p:nvPr/>
+        </p:nvSpPr>
+        <p:spPr>
+          <a:xfrm>
+            <a:off x="502920" y="228600"/>
+            <a:ext cx="502920" cy="502920"/>
+          </a:xfrm>
+          <a:prstGeom prst="rect">
+            <a:avLst/>
+          </a:prstGeom>
+          <a:noFill/>
+          <a:ln/>
+        </p:spPr>
+        <p:txBody>
+          <a:bodyPr wrap="square" rtlCol="0" anchor="ctr"/>
+          <a:lstStyle/>
+          <a:p>
+            <a:pPr algn="ctr" indent="0" marL="0">
+              <a:buNone/>
+            </a:pPr>
+            <a:r>
+              <a:rPr lang="en-US" sz="1600" b="1" dirty="0">
+                <a:solidFill>
+                  <a:srgbClr val="FFFFFF"/>
+                </a:solidFill>
+                <a:latin typeface="Malgun Gothic" pitchFamily="34" charset="0"/>
+                <a:ea typeface="Malgun Gothic" pitchFamily="34" charset="-122"/>
+                <a:cs typeface="Malgun Gothic" pitchFamily="34" charset="-120"/>
+              </a:rPr>
+              <a:t>23</a:t>
+            </a:r>
+            <a:endParaRPr lang="en-US" sz="1600" dirty="0"/>
+          </a:p>
+        </p:txBody>
+      </p:sp>
+      <p:sp>
+        <p:nvSpPr>
+          <p:cNvPr id="5" name="Text 3"/>
+          <p:cNvSpPr/>
+          <p:nvPr/>
+        </p:nvSpPr>
+        <p:spPr>
+          <a:xfrm>
+            <a:off x="1143000" y="0"/>
+            <a:ext cx="10957255" cy="960120"/>
+          </a:xfrm>
+          <a:prstGeom prst="rect">
+            <a:avLst/>
+          </a:prstGeom>
+          <a:noFill/>
+          <a:ln/>
+        </p:spPr>
+        <p:txBody>
+          <a:bodyPr wrap="square" rtlCol="0" anchor="ctr"/>
+          <a:lstStyle/>
+          <a:p>
+            <a:pPr indent="0" marL="0">
+              <a:buNone/>
+            </a:pPr>
+            <a:r>
+              <a:rPr lang="en-US" sz="2200" b="1" dirty="0">
+                <a:solidFill>
+                  <a:srgbClr val="FFFFFF"/>
+                </a:solidFill>
+                <a:latin typeface="Malgun Gothic" pitchFamily="34" charset="0"/>
+                <a:ea typeface="Malgun Gothic" pitchFamily="34" charset="-122"/>
+                <a:cs typeface="Malgun Gothic" pitchFamily="34" charset="-120"/>
+              </a:rPr>
+              <a:t>chapter-list</a:t>
+            </a:r>
+            <a:endParaRPr lang="en-US" sz="2200" dirty="0"/>
+          </a:p>
+        </p:txBody>
+      </p:sp>
+      <p:sp>
+        <p:nvSpPr>
+          <p:cNvPr id="6" name="Shape 4"/>
+          <p:cNvSpPr/>
+          <p:nvPr/>
+        </p:nvSpPr>
+        <p:spPr>
+          <a:xfrm>
+            <a:off x="457200" y="1143000"/>
+            <a:ext cx="11277295" cy="5052314"/>
+          </a:xfrm>
+          <a:prstGeom prst="roundRect">
+            <a:avLst>
+              <a:gd name="adj" fmla="val 1448"/>
+            </a:avLst>
+          </a:prstGeom>
+          <a:solidFill>
+            <a:srgbClr val="FFFFFF"/>
+          </a:solidFill>
+          <a:ln w="9525">
+            <a:solidFill>
+              <a:srgbClr val="C8E6DF"/>
+            </a:solidFill>
+            <a:prstDash val="solid"/>
+          </a:ln>
+        </p:spPr>
+      </p:sp>
+      <p:graphicFrame>
+        <p:nvGraphicFramePr>
+          <p:cNvPr id="27" name="Table 0"/>
+          <p:cNvGraphicFramePr>
+            <a:graphicFrameLocks noGrp="1"/>
+          </p:cNvGraphicFramePr>
+          <p:nvPr>
+            <p:extLst>
+              <p:ext uri="{D42A27DB-BD31-4B8C-83A1-F6EECF244321}">
+                <p14:modId xmlns:p14="http://schemas.microsoft.com/office/powerpoint/2010/main" val="1579011935"/>
+              </p:ext>
+            </p:extLst>
+          </p:nvPr>
+        </p:nvGraphicFramePr>
+        <p:xfrm>
+          <a:off x="685800" y="1325880"/>
+          <a:ext cx="10820095" cy="914400"/>
+        </p:xfrm>
+        <a:graphic>
+          <a:graphicData uri="http://schemas.openxmlformats.org/drawingml/2006/table">
+            <a:tbl>
+              <a:tblPr/>
+              <a:tblGrid>
+                <a:gridCol w="5410048"/>
+                <a:gridCol w="5410048"/>
+              </a:tblGrid>
+              <a:tr h="320040">
+                <a:tc>
+                  <a:txBody>
+                    <a:bodyPr/>
+                    <a:lstStyle/>
+                    <a:p>
+                      <a:pPr indent="0" marL="0">
+                        <a:buNone/>
+                      </a:pPr>
+                      <a:r>
+                        <a:rPr lang="en-US" sz="1100" b="1" dirty="0">
+                          <a:solidFill>
+                            <a:srgbClr val="FFFFFF"/>
+                          </a:solidFill>
+                          <a:latin typeface="Malgun Gothic" pitchFamily="34" charset="0"/>
+                          <a:ea typeface="Malgun Gothic" pitchFamily="34" charset="-122"/>
+                          <a:cs typeface="Malgun Gothic" pitchFamily="34" charset="-120"/>
+                        </a:rPr>
+                        <a:t>항목</a:t>
+                      </a:r>
+                      <a:endParaRPr lang="en-US" sz="1100" dirty="0">
+                        <a:latin typeface="Malgun Gothic" charset="0"/>
+                        <a:ea typeface="Malgun Gothic" charset="0"/>
+                        <a:cs typeface="Malgun Gothic" charset="0"/>
+                      </a:endParaRPr>
+                    </a:p>
+                  </a:txBody>
+                  <a:tcPr marL="91440" marR="91440" marT="45720" marB="45720">
+                    <a:lnL w="12700" cap="flat" cmpd="sng" algn="ctr">
+                      <a:solidFill>
+                        <a:srgbClr val="C8E6DF"/>
+                      </a:solidFill>
+                      <a:prstDash val="solid"/>
+                      <a:round/>
+                      <a:headEnd type="none" w="med" len="med"/>
+                      <a:tailEnd type="none" w="med" len="med"/>
+                    </a:lnL>
+                    <a:lnR w="12700" cap="flat" cmpd="sng" algn="ctr">
+                      <a:solidFill>
+                        <a:srgbClr val="C8E6DF"/>
+                      </a:solidFill>
+                      <a:prstDash val="solid"/>
+                      <a:round/>
+                      <a:headEnd type="none" w="med" len="med"/>
+                      <a:tailEnd type="none" w="med" len="med"/>
+                    </a:lnR>
+                    <a:lnT w="12700" cap="flat" cmpd="sng" algn="ctr">
+                      <a:solidFill>
+                        <a:srgbClr val="C8E6DF"/>
+                      </a:solidFill>
+                      <a:prstDash val="solid"/>
+                      <a:round/>
+                      <a:headEnd type="none" w="med" len="med"/>
+                      <a:tailEnd type="none" w="med" len="med"/>
+                    </a:lnT>
+                    <a:lnB w="12700" cap="flat" cmpd="sng" algn="ctr">
+                      <a:solidFill>
+                        <a:srgbClr val="C8E6DF"/>
+                      </a:solidFill>
+                      <a:prstDash val="solid"/>
+                      <a:round/>
+                      <a:headEnd type="none" w="med" len="med"/>
+                      <a:tailEnd type="none" w="med" len="med"/>
+                    </a:lnB>
+                    <a:solidFill>
+                      <a:srgbClr val="10A37F"/>
+                    </a:solidFill>
+                  </a:tcPr>
+                </a:tc>
+                <a:tc>
+                  <a:txBody>
+                    <a:bodyPr/>
+                    <a:lstStyle/>
+                    <a:p>
+                      <a:pPr indent="0" marL="0">
+                        <a:buNone/>
+                      </a:pPr>
+                      <a:r>
+                        <a:rPr lang="en-US" sz="1100" b="1" dirty="0">
+                          <a:solidFill>
+                            <a:srgbClr val="FFFFFF"/>
+                          </a:solidFill>
+                          <a:latin typeface="Malgun Gothic" pitchFamily="34" charset="0"/>
+                          <a:ea typeface="Malgun Gothic" pitchFamily="34" charset="-122"/>
+                          <a:cs typeface="Malgun Gothic" pitchFamily="34" charset="-120"/>
+                        </a:rPr>
+                        <a:t>내용</a:t>
+                      </a:r>
+                      <a:endParaRPr lang="en-US" sz="1100" dirty="0">
+                        <a:latin typeface="Malgun Gothic" charset="0"/>
+                        <a:ea typeface="Malgun Gothic" charset="0"/>
+                        <a:cs typeface="Malgun Gothic" charset="0"/>
+                      </a:endParaRPr>
+                    </a:p>
+                  </a:txBody>
+                  <a:tcPr marL="91440" marR="91440" marT="45720" marB="45720">
+                    <a:lnL w="12700" cap="flat" cmpd="sng" algn="ctr">
+                      <a:solidFill>
+                        <a:srgbClr val="C8E6DF"/>
+                      </a:solidFill>
+                      <a:prstDash val="solid"/>
+                      <a:round/>
+                      <a:headEnd type="none" w="med" len="med"/>
+                      <a:tailEnd type="none" w="med" len="med"/>
+                    </a:lnL>
+                    <a:lnR w="12700" cap="flat" cmpd="sng" algn="ctr">
+                      <a:solidFill>
+                        <a:srgbClr val="C8E6DF"/>
+                      </a:solidFill>
+                      <a:prstDash val="solid"/>
+                      <a:round/>
+                      <a:headEnd type="none" w="med" len="med"/>
+                      <a:tailEnd type="none" w="med" len="med"/>
+                    </a:lnR>
+                    <a:lnT w="12700" cap="flat" cmpd="sng" algn="ctr">
+                      <a:solidFill>
+                        <a:srgbClr val="C8E6DF"/>
+                      </a:solidFill>
+                      <a:prstDash val="solid"/>
+                      <a:round/>
+                      <a:headEnd type="none" w="med" len="med"/>
+                      <a:tailEnd type="none" w="med" len="med"/>
+                    </a:lnT>
+                    <a:lnB w="12700" cap="flat" cmpd="sng" algn="ctr">
+                      <a:solidFill>
+                        <a:srgbClr val="C8E6DF"/>
+                      </a:solidFill>
+                      <a:prstDash val="solid"/>
+                      <a:round/>
+                      <a:headEnd type="none" w="med" len="med"/>
+                      <a:tailEnd type="none" w="med" len="med"/>
+                    </a:lnB>
+                    <a:solidFill>
+                      <a:srgbClr val="10A37F"/>
+                    </a:solidFill>
+                  </a:tcPr>
+                </a:tc>
+              </a:tr>
+              <a:tr h="256032">
+                <a:tc>
+                  <a:txBody>
+                    <a:bodyPr/>
+                    <a:lstStyle/>
+                    <a:p>
+                      <a:pPr indent="0" marL="0">
+                        <a:buNone/>
+                      </a:pPr>
+                      <a:r>
+                        <a:rPr lang="en-US" sz="1000" dirty="0">
+                          <a:solidFill>
+                            <a:srgbClr val="475569"/>
+                          </a:solidFill>
+                          <a:latin typeface="Malgun Gothic" pitchFamily="34" charset="0"/>
+                          <a:ea typeface="Malgun Gothic" pitchFamily="34" charset="-122"/>
+                          <a:cs typeface="Malgun Gothic" pitchFamily="34" charset="-120"/>
+                        </a:rPr>
+                        <a:t>숏코드 명</a:t>
+                      </a:r>
+                      <a:endParaRPr lang="en-US" sz="1000" dirty="0">
+                        <a:latin typeface="Malgun Gothic" charset="0"/>
+                        <a:ea typeface="Malgun Gothic" charset="0"/>
+                        <a:cs typeface="Malgun Gothic" charset="0"/>
+                      </a:endParaRPr>
+                    </a:p>
+                  </a:txBody>
+                  <a:tcPr marL="91440" marR="91440" marT="45720" marB="45720">
+                    <a:lnL w="12700" cap="flat" cmpd="sng" algn="ctr">
+                      <a:solidFill>
+                        <a:srgbClr val="C8E6DF"/>
+                      </a:solidFill>
+                      <a:prstDash val="solid"/>
+                      <a:round/>
+                      <a:headEnd type="none" w="med" len="med"/>
+                      <a:tailEnd type="none" w="med" len="med"/>
+                    </a:lnL>
+                    <a:lnR w="12700" cap="flat" cmpd="sng" algn="ctr">
+                      <a:solidFill>
+                        <a:srgbClr val="C8E6DF"/>
+                      </a:solidFill>
+                      <a:prstDash val="solid"/>
+                      <a:round/>
+                      <a:headEnd type="none" w="med" len="med"/>
+                      <a:tailEnd type="none" w="med" len="med"/>
+                    </a:lnR>
+                    <a:lnT w="12700" cap="flat" cmpd="sng" algn="ctr">
+                      <a:solidFill>
+                        <a:srgbClr val="C8E6DF"/>
+                      </a:solidFill>
+                      <a:prstDash val="solid"/>
+                      <a:round/>
+                      <a:headEnd type="none" w="med" len="med"/>
+                      <a:tailEnd type="none" w="med" len="med"/>
+                    </a:lnT>
+                    <a:lnB w="12700" cap="flat" cmpd="sng" algn="ctr">
+                      <a:solidFill>
+                        <a:srgbClr val="C8E6DF"/>
+                      </a:solidFill>
+                      <a:prstDash val="solid"/>
+                      <a:round/>
+                      <a:headEnd type="none" w="med" len="med"/>
+                      <a:tailEnd type="none" w="med" len="med"/>
+                    </a:lnB>
+                  </a:tcPr>
+                </a:tc>
+                <a:tc>
+                  <a:txBody>
+                    <a:bodyPr/>
+                    <a:lstStyle/>
+                    <a:p>
+                      <a:pPr indent="0" marL="0">
+                        <a:buNone/>
+                      </a:pPr>
+                      <a:r>
+                        <a:rPr lang="en-US" sz="1000" dirty="0">
+                          <a:solidFill>
+                            <a:srgbClr val="475569"/>
+                          </a:solidFill>
+                          <a:latin typeface="Malgun Gothic" pitchFamily="34" charset="0"/>
+                          <a:ea typeface="Malgun Gothic" pitchFamily="34" charset="-122"/>
+                          <a:cs typeface="Malgun Gothic" pitchFamily="34" charset="-120"/>
+                        </a:rPr>
+                        <a:t>chapter-list</a:t>
+                      </a:r>
+                      <a:endParaRPr lang="en-US" sz="1000" dirty="0">
+                        <a:latin typeface="Malgun Gothic" charset="0"/>
+                        <a:ea typeface="Malgun Gothic" charset="0"/>
+                        <a:cs typeface="Malgun Gothic" charset="0"/>
+                      </a:endParaRPr>
+                    </a:p>
+                  </a:txBody>
+                  <a:tcPr marL="91440" marR="91440" marT="45720" marB="45720">
+                    <a:lnL w="12700" cap="flat" cmpd="sng" algn="ctr">
+                      <a:solidFill>
+                        <a:srgbClr val="C8E6DF"/>
+                      </a:solidFill>
+                      <a:prstDash val="solid"/>
+                      <a:round/>
+                      <a:headEnd type="none" w="med" len="med"/>
+                      <a:tailEnd type="none" w="med" len="med"/>
+                    </a:lnL>
+                    <a:lnR w="12700" cap="flat" cmpd="sng" algn="ctr">
+                      <a:solidFill>
+                        <a:srgbClr val="C8E6DF"/>
+                      </a:solidFill>
+                      <a:prstDash val="solid"/>
+                      <a:round/>
+                      <a:headEnd type="none" w="med" len="med"/>
+                      <a:tailEnd type="none" w="med" len="med"/>
+                    </a:lnR>
+                    <a:lnT w="12700" cap="flat" cmpd="sng" algn="ctr">
+                      <a:solidFill>
+                        <a:srgbClr val="C8E6DF"/>
+                      </a:solidFill>
+                      <a:prstDash val="solid"/>
+                      <a:round/>
+                      <a:headEnd type="none" w="med" len="med"/>
+                      <a:tailEnd type="none" w="med" len="med"/>
+                    </a:lnT>
+                    <a:lnB w="12700" cap="flat" cmpd="sng" algn="ctr">
+                      <a:solidFill>
+                        <a:srgbClr val="C8E6DF"/>
+                      </a:solidFill>
+                      <a:prstDash val="solid"/>
+                      <a:round/>
+                      <a:headEnd type="none" w="med" len="med"/>
+                      <a:tailEnd type="none" w="med" len="med"/>
+                    </a:lnB>
+                  </a:tcPr>
+                </a:tc>
+              </a:tr>
+              <a:tr h="256032">
+                <a:tc>
+                  <a:txBody>
+                    <a:bodyPr/>
+                    <a:lstStyle/>
+                    <a:p>
+                      <a:pPr indent="0" marL="0">
+                        <a:buNone/>
+                      </a:pPr>
+                      <a:r>
+                        <a:rPr lang="en-US" sz="1000" dirty="0">
+                          <a:solidFill>
+                            <a:srgbClr val="475569"/>
+                          </a:solidFill>
+                          <a:latin typeface="Malgun Gothic" pitchFamily="34" charset="0"/>
+                          <a:ea typeface="Malgun Gothic" pitchFamily="34" charset="-122"/>
+                          <a:cs typeface="Malgun Gothic" pitchFamily="34" charset="-120"/>
+                        </a:rPr>
+                        <a:t>구현내용</a:t>
+                      </a:r>
+                      <a:endParaRPr lang="en-US" sz="1000" dirty="0">
+                        <a:latin typeface="Malgun Gothic" charset="0"/>
+                        <a:ea typeface="Malgun Gothic" charset="0"/>
+                        <a:cs typeface="Malgun Gothic" charset="0"/>
+                      </a:endParaRPr>
+                    </a:p>
+                  </a:txBody>
+                  <a:tcPr marL="91440" marR="91440" marT="45720" marB="45720">
+                    <a:lnL w="12700" cap="flat" cmpd="sng" algn="ctr">
+                      <a:solidFill>
+                        <a:srgbClr val="C8E6DF"/>
+                      </a:solidFill>
+                      <a:prstDash val="solid"/>
+                      <a:round/>
+                      <a:headEnd type="none" w="med" len="med"/>
+                      <a:tailEnd type="none" w="med" len="med"/>
+                    </a:lnL>
+                    <a:lnR w="12700" cap="flat" cmpd="sng" algn="ctr">
+                      <a:solidFill>
+                        <a:srgbClr val="C8E6DF"/>
+                      </a:solidFill>
+                      <a:prstDash val="solid"/>
+                      <a:round/>
+                      <a:headEnd type="none" w="med" len="med"/>
+                      <a:tailEnd type="none" w="med" len="med"/>
+                    </a:lnR>
+                    <a:lnT w="12700" cap="flat" cmpd="sng" algn="ctr">
+                      <a:solidFill>
+                        <a:srgbClr val="C8E6DF"/>
+                      </a:solidFill>
+                      <a:prstDash val="solid"/>
+                      <a:round/>
+                      <a:headEnd type="none" w="med" len="med"/>
+                      <a:tailEnd type="none" w="med" len="med"/>
+                    </a:lnT>
+                    <a:lnB w="12700" cap="flat" cmpd="sng" algn="ctr">
+                      <a:solidFill>
+                        <a:srgbClr val="C8E6DF"/>
+                      </a:solidFill>
+                      <a:prstDash val="solid"/>
+                      <a:round/>
+                      <a:headEnd type="none" w="med" len="med"/>
+                      <a:tailEnd type="none" w="med" len="med"/>
+                    </a:lnB>
+                  </a:tcPr>
+                </a:tc>
+                <a:tc>
+                  <a:txBody>
+                    <a:bodyPr/>
+                    <a:lstStyle/>
+                    <a:p>
+                      <a:pPr indent="0" marL="0">
+                        <a:buNone/>
+                      </a:pPr>
+                      <a:r>
+                        <a:rPr lang="en-US" sz="1000" dirty="0">
+                          <a:solidFill>
+                            <a:srgbClr val="475569"/>
+                          </a:solidFill>
+                          <a:latin typeface="Malgun Gothic" pitchFamily="34" charset="0"/>
+                          <a:ea typeface="Malgun Gothic" pitchFamily="34" charset="-122"/>
+                          <a:cs typeface="Malgun Gothic" pitchFamily="34" charset="-120"/>
+                        </a:rPr>
+                        <a:t>세부 목차 및 챕터 리스트 숏코드입니다. 챕터 번호와 뱃지 속성에 따라 이쁜 HSL 배지 색상이 자동 매핑됩니다.</a:t>
+                      </a:r>
+                      <a:endParaRPr lang="en-US" sz="1000" dirty="0">
+                        <a:latin typeface="Malgun Gothic" charset="0"/>
+                        <a:ea typeface="Malgun Gothic" charset="0"/>
+                        <a:cs typeface="Malgun Gothic" charset="0"/>
+                      </a:endParaRPr>
+                    </a:p>
+                  </a:txBody>
+                  <a:tcPr marL="91440" marR="91440" marT="45720" marB="45720">
+                    <a:lnL w="12700" cap="flat" cmpd="sng" algn="ctr">
+                      <a:solidFill>
+                        <a:srgbClr val="C8E6DF"/>
+                      </a:solidFill>
+                      <a:prstDash val="solid"/>
+                      <a:round/>
+                      <a:headEnd type="none" w="med" len="med"/>
+                      <a:tailEnd type="none" w="med" len="med"/>
+                    </a:lnL>
+                    <a:lnR w="12700" cap="flat" cmpd="sng" algn="ctr">
+                      <a:solidFill>
+                        <a:srgbClr val="C8E6DF"/>
+                      </a:solidFill>
+                      <a:prstDash val="solid"/>
+                      <a:round/>
+                      <a:headEnd type="none" w="med" len="med"/>
+                      <a:tailEnd type="none" w="med" len="med"/>
+                    </a:lnR>
+                    <a:lnT w="12700" cap="flat" cmpd="sng" algn="ctr">
+                      <a:solidFill>
+                        <a:srgbClr val="C8E6DF"/>
+                      </a:solidFill>
+                      <a:prstDash val="solid"/>
+                      <a:round/>
+                      <a:headEnd type="none" w="med" len="med"/>
+                      <a:tailEnd type="none" w="med" len="med"/>
+                    </a:lnT>
+                    <a:lnB w="12700" cap="flat" cmpd="sng" algn="ctr">
+                      <a:solidFill>
+                        <a:srgbClr val="C8E6DF"/>
+                      </a:solidFill>
+                      <a:prstDash val="solid"/>
+                      <a:round/>
+                      <a:headEnd type="none" w="med" len="med"/>
+                      <a:tailEnd type="none" w="med" len="med"/>
+                    </a:lnB>
+                  </a:tcPr>
+                </a:tc>
+              </a:tr>
+            </a:tbl>
+          </a:graphicData>
+        </a:graphic>
+      </p:graphicFrame>
+      <p:sp>
+        <p:nvSpPr>
+          <p:cNvPr id="8" name="Text 5"/>
+          <p:cNvSpPr/>
+          <p:nvPr/>
+        </p:nvSpPr>
+        <p:spPr>
+          <a:xfrm>
+            <a:off x="685800" y="2295144"/>
+            <a:ext cx="10820095" cy="237490"/>
+          </a:xfrm>
+          <a:prstGeom prst="rect">
+            <a:avLst/>
+          </a:prstGeom>
+          <a:noFill/>
+          <a:ln/>
+        </p:spPr>
+        <p:txBody>
+          <a:bodyPr wrap="square" rtlCol="0" anchor="t"/>
+          <a:lstStyle/>
+          <a:p>
+            <a:pPr indent="0" marL="0">
+              <a:buNone/>
+            </a:pPr>
+            <a:r>
+              <a:rPr lang="en-US" sz="1100" dirty="0">
+                <a:solidFill>
+                  <a:srgbClr val="475569"/>
+                </a:solidFill>
+                <a:latin typeface="Malgun Gothic" pitchFamily="34" charset="0"/>
+                <a:ea typeface="Malgun Gothic" pitchFamily="34" charset="-122"/>
+                <a:cs typeface="Malgun Gothic" pitchFamily="34" charset="-120"/>
+              </a:rPr>
+              <a:t>숏코드 입력내용</a:t>
+            </a:r>
+            <a:endParaRPr lang="en-US" sz="1100" dirty="0"/>
+          </a:p>
+        </p:txBody>
+      </p:sp>
+      <p:sp>
+        <p:nvSpPr>
+          <p:cNvPr id="9" name="Shape 6"/>
+          <p:cNvSpPr/>
+          <p:nvPr/>
+        </p:nvSpPr>
+        <p:spPr>
+          <a:xfrm>
+            <a:off x="685800" y="2669794"/>
+            <a:ext cx="10820095" cy="3205480"/>
+          </a:xfrm>
+          <a:prstGeom prst="rect">
+            <a:avLst/>
+          </a:prstGeom>
+          <a:solidFill>
+            <a:srgbClr val="0F172A"/>
+          </a:solidFill>
+          <a:ln w="9525">
+            <a:solidFill>
+              <a:srgbClr val="C8E6DF"/>
+            </a:solidFill>
+            <a:prstDash val="solid"/>
+          </a:ln>
+        </p:spPr>
+      </p:sp>
+      <p:sp>
+        <p:nvSpPr>
+          <p:cNvPr id="10" name="Text 7"/>
+          <p:cNvSpPr/>
+          <p:nvPr/>
+        </p:nvSpPr>
+        <p:spPr>
+          <a:xfrm>
+            <a:off x="795528" y="2742946"/>
+            <a:ext cx="10600639" cy="3114040"/>
+          </a:xfrm>
+          <a:prstGeom prst="rect">
+            <a:avLst/>
+          </a:prstGeom>
+          <a:noFill/>
+          <a:ln/>
+        </p:spPr>
+        <p:txBody>
+          <a:bodyPr wrap="square" rtlCol="0" anchor="t"/>
+          <a:lstStyle/>
+          <a:p>
+            <a:pPr indent="0" marL="0">
+              <a:buNone/>
+            </a:pPr>
+            <a:r>
+              <a:rPr lang="en-US" sz="1000" dirty="0">
+                <a:solidFill>
+                  <a:srgbClr val="A8B2D8"/>
+                </a:solidFill>
+                <a:latin typeface="Consolas" pitchFamily="34" charset="0"/>
+                <a:ea typeface="Consolas" pitchFamily="34" charset="-122"/>
+                <a:cs typeface="Consolas" pitchFamily="34" charset="-120"/>
+              </a:rPr>
+              <a:t>\::: chapter-list</a:t>
+            </a:r>
+            <a:endParaRPr lang="en-US" sz="1000" dirty="0"/>
+          </a:p>
+          <a:p>
+            <a:pPr indent="0" marL="0">
+              <a:buNone/>
+            </a:pPr>
+            <a:r>
+              <a:rPr lang="en-US" sz="1000" dirty="0">
+                <a:solidFill>
+                  <a:srgbClr val="A8B2D8"/>
+                </a:solidFill>
+                <a:latin typeface="Consolas" pitchFamily="34" charset="0"/>
+                <a:ea typeface="Consolas" pitchFamily="34" charset="-122"/>
+                <a:cs typeface="Consolas" pitchFamily="34" charset="-120"/>
+              </a:rPr>
+              <a:t>- icon: "01"</a:t>
+            </a:r>
+            <a:endParaRPr lang="en-US" sz="1000" dirty="0"/>
+          </a:p>
+          <a:p>
+            <a:pPr indent="0" marL="0">
+              <a:buNone/>
+            </a:pPr>
+            <a:r>
+              <a:rPr lang="en-US" sz="1000" dirty="0">
+                <a:solidFill>
+                  <a:srgbClr val="A8B2D8"/>
+                </a:solidFill>
+                <a:latin typeface="Consolas" pitchFamily="34" charset="0"/>
+                <a:ea typeface="Consolas" pitchFamily="34" charset="-122"/>
+                <a:cs typeface="Consolas" pitchFamily="34" charset="-120"/>
+              </a:rPr>
+              <a:t>  title: "바이브코딩이란?"</a:t>
+            </a:r>
+            <a:endParaRPr lang="en-US" sz="1000" dirty="0"/>
+          </a:p>
+          <a:p>
+            <a:pPr indent="0" marL="0">
+              <a:buNone/>
+            </a:pPr>
+            <a:r>
+              <a:rPr lang="en-US" sz="1000" dirty="0">
+                <a:solidFill>
+                  <a:srgbClr val="A8B2D8"/>
+                </a:solidFill>
+                <a:latin typeface="Consolas" pitchFamily="34" charset="0"/>
+                <a:ea typeface="Consolas" pitchFamily="34" charset="-122"/>
+                <a:cs typeface="Consolas" pitchFamily="34" charset="-120"/>
+              </a:rPr>
+              <a:t>  desc: "Karpathy 발언 배경 · 전통 코딩 vs 바이브코딩 · LLM 발전"</a:t>
+            </a:r>
+            <a:endParaRPr lang="en-US" sz="1000" dirty="0"/>
+          </a:p>
+          <a:p>
+            <a:pPr indent="0" marL="0">
+              <a:buNone/>
+            </a:pPr>
+            <a:r>
+              <a:rPr lang="en-US" sz="1000" dirty="0">
+                <a:solidFill>
+                  <a:srgbClr val="A8B2D8"/>
+                </a:solidFill>
+                <a:latin typeface="Consolas" pitchFamily="34" charset="0"/>
+                <a:ea typeface="Consolas" pitchFamily="34" charset="-122"/>
+                <a:cs typeface="Consolas" pitchFamily="34" charset="-120"/>
+              </a:rPr>
+              <a:t>  tag: "개념"</a:t>
+            </a:r>
+            <a:endParaRPr lang="en-US" sz="1000" dirty="0"/>
+          </a:p>
+          <a:p>
+            <a:pPr indent="0" marL="0">
+              <a:buNone/>
+            </a:pPr>
+            <a:r>
+              <a:rPr lang="en-US" sz="1000" dirty="0">
+                <a:solidFill>
+                  <a:srgbClr val="A8B2D8"/>
+                </a:solidFill>
+                <a:latin typeface="Consolas" pitchFamily="34" charset="0"/>
+                <a:ea typeface="Consolas" pitchFamily="34" charset="-122"/>
+                <a:cs typeface="Consolas" pitchFamily="34" charset="-120"/>
+              </a:rPr>
+              <a:t>- icon: "02"</a:t>
+            </a:r>
+            <a:endParaRPr lang="en-US" sz="1000" dirty="0"/>
+          </a:p>
+          <a:p>
+            <a:pPr indent="0" marL="0">
+              <a:buNone/>
+            </a:pPr>
+            <a:r>
+              <a:rPr lang="en-US" sz="1000" dirty="0">
+                <a:solidFill>
+                  <a:srgbClr val="A8B2D8"/>
+                </a:solidFill>
+                <a:latin typeface="Consolas" pitchFamily="34" charset="0"/>
+                <a:ea typeface="Consolas" pitchFamily="34" charset="-122"/>
+                <a:cs typeface="Consolas" pitchFamily="34" charset="-120"/>
+              </a:rPr>
+              <a:t>  title: "에이전트 코딩이란?"</a:t>
+            </a:r>
+            <a:endParaRPr lang="en-US" sz="1000" dirty="0"/>
+          </a:p>
+          <a:p>
+            <a:pPr indent="0" marL="0">
+              <a:buNone/>
+            </a:pPr>
+            <a:r>
+              <a:rPr lang="en-US" sz="1000" dirty="0">
+                <a:solidFill>
+                  <a:srgbClr val="A8B2D8"/>
+                </a:solidFill>
+                <a:latin typeface="Consolas" pitchFamily="34" charset="0"/>
+                <a:ea typeface="Consolas" pitchFamily="34" charset="-122"/>
+                <a:cs typeface="Consolas" pitchFamily="34" charset="-120"/>
+              </a:rPr>
+              <a:t>  desc: "계획→실행→수정 루프 · 레벨 1~5 스펙트럼 · 바이브코딩과 차이"</a:t>
+            </a:r>
+            <a:endParaRPr lang="en-US" sz="1000" dirty="0"/>
+          </a:p>
+          <a:p>
+            <a:pPr indent="0" marL="0">
+              <a:buNone/>
+            </a:pPr>
+            <a:r>
+              <a:rPr lang="en-US" sz="1000" dirty="0">
+                <a:solidFill>
+                  <a:srgbClr val="A8B2D8"/>
+                </a:solidFill>
+                <a:latin typeface="Consolas" pitchFamily="34" charset="0"/>
+                <a:ea typeface="Consolas" pitchFamily="34" charset="-122"/>
+                <a:cs typeface="Consolas" pitchFamily="34" charset="-120"/>
+              </a:rPr>
+              <a:t>  tag: "개념"</a:t>
+            </a:r>
+            <a:endParaRPr lang="en-US" sz="1000" dirty="0"/>
+          </a:p>
+          <a:p>
+            <a:pPr indent="0" marL="0">
+              <a:buNone/>
+            </a:pPr>
+            <a:r>
+              <a:rPr lang="en-US" sz="1000" dirty="0">
+                <a:solidFill>
+                  <a:srgbClr val="A8B2D8"/>
+                </a:solidFill>
+                <a:latin typeface="Consolas" pitchFamily="34" charset="0"/>
+                <a:ea typeface="Consolas" pitchFamily="34" charset="-122"/>
+                <a:cs typeface="Consolas" pitchFamily="34" charset="-120"/>
+              </a:rPr>
+              <a:t>- icon: "04"</a:t>
+            </a:r>
+            <a:endParaRPr lang="en-US" sz="1000" dirty="0"/>
+          </a:p>
+          <a:p>
+            <a:pPr indent="0" marL="0">
+              <a:buNone/>
+            </a:pPr>
+            <a:r>
+              <a:rPr lang="en-US" sz="1000" dirty="0">
+                <a:solidFill>
+                  <a:srgbClr val="A8B2D8"/>
+                </a:solidFill>
+                <a:latin typeface="Consolas" pitchFamily="34" charset="0"/>
+                <a:ea typeface="Consolas" pitchFamily="34" charset="-122"/>
+                <a:cs typeface="Consolas" pitchFamily="34" charset="-120"/>
+              </a:rPr>
+              <a:t>  title: "첫 대화: 프롬프트 설계"</a:t>
+            </a:r>
+            <a:endParaRPr lang="en-US" sz="1000" dirty="0"/>
+          </a:p>
+          <a:p>
+            <a:pPr indent="0" marL="0">
+              <a:buNone/>
+            </a:pPr>
+            <a:r>
+              <a:rPr lang="en-US" sz="1000" dirty="0">
+                <a:solidFill>
+                  <a:srgbClr val="A8B2D8"/>
+                </a:solidFill>
+                <a:latin typeface="Consolas" pitchFamily="34" charset="0"/>
+                <a:ea typeface="Consolas" pitchFamily="34" charset="-122"/>
+                <a:cs typeface="Consolas" pitchFamily="34" charset="-120"/>
+              </a:rPr>
+              <a:t>  desc: "요구사항 명세 · 컨텍스트 주입 전략 · SKILL.md 재사용 지시"</a:t>
+            </a:r>
+            <a:endParaRPr lang="en-US" sz="1000" dirty="0"/>
+          </a:p>
+          <a:p>
+            <a:pPr indent="0" marL="0">
+              <a:buNone/>
+            </a:pPr>
+            <a:r>
+              <a:rPr lang="en-US" sz="1000" dirty="0">
+                <a:solidFill>
+                  <a:srgbClr val="A8B2D8"/>
+                </a:solidFill>
+                <a:latin typeface="Consolas" pitchFamily="34" charset="0"/>
+                <a:ea typeface="Consolas" pitchFamily="34" charset="-122"/>
+                <a:cs typeface="Consolas" pitchFamily="34" charset="-120"/>
+              </a:rPr>
+              <a:t>  tag: "실습"</a:t>
+            </a:r>
+            <a:endParaRPr lang="en-US" sz="1000" dirty="0"/>
+          </a:p>
+          <a:p>
+            <a:pPr indent="0" marL="0">
+              <a:buNone/>
+            </a:pPr>
+            <a:r>
+              <a:rPr lang="en-US" sz="1000" dirty="0">
+                <a:solidFill>
+                  <a:srgbClr val="A8B2D8"/>
+                </a:solidFill>
+                <a:latin typeface="Consolas" pitchFamily="34" charset="0"/>
+                <a:ea typeface="Consolas" pitchFamily="34" charset="-122"/>
+                <a:cs typeface="Consolas" pitchFamily="34" charset="-120"/>
+              </a:rPr>
+              <a:t>\:::</a:t>
+            </a:r>
+            <a:endParaRPr lang="en-US" sz="1000" dirty="0"/>
+          </a:p>
+        </p:txBody>
+      </p:sp>
+    </p:spTree>
+  </p:cSld>
+  <p:clrMapOvr>
+    <a:masterClrMapping/>
+  </p:clrMapOvr>
+</p:sld>
+</file>
+
+<file path=ppt/slides/slide27.xml><?xml version="1.0" encoding="utf-8"?>
+<p:sld xmlns:a="http://schemas.openxmlformats.org/drawingml/2006/main" xmlns:r="http://schemas.openxmlformats.org/officeDocument/2006/relationships" xmlns:p="http://schemas.openxmlformats.org/presentationml/2006/main">
+  <p:cSld name="Slide 27">
+    <p:bg>
+      <p:bgPr>
+        <a:solidFill>
+          <a:srgbClr val="FFFFFF"/>
+        </a:solidFill>
+      </p:bgPr>
+    </p:bg>
+    <p:spTree>
+      <p:nvGrpSpPr>
+        <p:cNvPr id="1" name=""/>
+        <p:cNvGrpSpPr/>
+        <p:nvPr/>
+      </p:nvGrpSpPr>
+      <p:grpSpPr>
+        <a:xfrm>
+          <a:off x="0" y="0"/>
+          <a:ext cx="0" cy="0"/>
+          <a:chOff x="0" y="0"/>
+          <a:chExt cx="0" cy="0"/>
+        </a:xfrm>
+      </p:grpSpPr>
+      <p:sp>
+        <p:nvSpPr>
+          <p:cNvPr id="2" name="Shape 0"/>
+          <p:cNvSpPr/>
+          <p:nvPr/>
+        </p:nvSpPr>
+        <p:spPr>
+          <a:xfrm>
+            <a:off x="0" y="0"/>
+            <a:ext cx="12191695" cy="960120"/>
+          </a:xfrm>
+          <a:prstGeom prst="rect">
+            <a:avLst/>
+          </a:prstGeom>
+          <a:solidFill>
+            <a:srgbClr val="0F172A"/>
+          </a:solidFill>
+          <a:ln w="12700">
+            <a:solidFill>
+              <a:srgbClr val="0F172A"/>
+            </a:solidFill>
+            <a:prstDash val="solid"/>
+          </a:ln>
+        </p:spPr>
+      </p:sp>
+      <p:sp>
+        <p:nvSpPr>
+          <p:cNvPr id="3" name="Shape 1"/>
+          <p:cNvSpPr/>
+          <p:nvPr/>
+        </p:nvSpPr>
+        <p:spPr>
+          <a:xfrm>
+            <a:off x="502920" y="228600"/>
+            <a:ext cx="502920" cy="502920"/>
+          </a:xfrm>
+          <a:prstGeom prst="roundRect">
+            <a:avLst>
+              <a:gd name="adj" fmla="val 18182"/>
+            </a:avLst>
+          </a:prstGeom>
+          <a:solidFill>
+            <a:srgbClr val="10A37F"/>
+          </a:solidFill>
+          <a:ln w="12700">
+            <a:solidFill>
+              <a:srgbClr val="10A37F"/>
+            </a:solidFill>
+            <a:prstDash val="solid"/>
+          </a:ln>
+        </p:spPr>
+      </p:sp>
+      <p:sp>
+        <p:nvSpPr>
+          <p:cNvPr id="4" name="Text 2"/>
+          <p:cNvSpPr/>
+          <p:nvPr/>
+        </p:nvSpPr>
+        <p:spPr>
+          <a:xfrm>
+            <a:off x="502920" y="228600"/>
+            <a:ext cx="502920" cy="502920"/>
+          </a:xfrm>
+          <a:prstGeom prst="rect">
+            <a:avLst/>
+          </a:prstGeom>
+          <a:noFill/>
+          <a:ln/>
+        </p:spPr>
+        <p:txBody>
+          <a:bodyPr wrap="square" rtlCol="0" anchor="ctr"/>
+          <a:lstStyle/>
+          <a:p>
+            <a:pPr algn="ctr" indent="0" marL="0">
+              <a:buNone/>
+            </a:pPr>
+            <a:r>
+              <a:rPr lang="en-US" sz="1600" b="1" dirty="0">
+                <a:solidFill>
+                  <a:srgbClr val="FFFFFF"/>
+                </a:solidFill>
+                <a:latin typeface="Malgun Gothic" pitchFamily="34" charset="0"/>
+                <a:ea typeface="Malgun Gothic" pitchFamily="34" charset="-122"/>
+                <a:cs typeface="Malgun Gothic" pitchFamily="34" charset="-120"/>
+              </a:rPr>
+              <a:t>24</a:t>
+            </a:r>
+            <a:endParaRPr lang="en-US" sz="1600" dirty="0"/>
+          </a:p>
+        </p:txBody>
+      </p:sp>
+      <p:sp>
+        <p:nvSpPr>
+          <p:cNvPr id="5" name="Text 3"/>
+          <p:cNvSpPr/>
+          <p:nvPr/>
+        </p:nvSpPr>
+        <p:spPr>
+          <a:xfrm>
+            <a:off x="1143000" y="0"/>
+            <a:ext cx="10957255" cy="960120"/>
+          </a:xfrm>
+          <a:prstGeom prst="rect">
+            <a:avLst/>
+          </a:prstGeom>
+          <a:noFill/>
+          <a:ln/>
+        </p:spPr>
+        <p:txBody>
+          <a:bodyPr wrap="square" rtlCol="0" anchor="ctr"/>
+          <a:lstStyle/>
+          <a:p>
+            <a:pPr indent="0" marL="0">
+              <a:buNone/>
+            </a:pPr>
+            <a:r>
+              <a:rPr lang="en-US" sz="2200" b="1" dirty="0">
+                <a:solidFill>
+                  <a:srgbClr val="FFFFFF"/>
+                </a:solidFill>
+                <a:latin typeface="Malgun Gothic" pitchFamily="34" charset="0"/>
+                <a:ea typeface="Malgun Gothic" pitchFamily="34" charset="-122"/>
+                <a:cs typeface="Malgun Gothic" pitchFamily="34" charset="-120"/>
+              </a:rPr>
+              <a:t>summary-bar</a:t>
+            </a:r>
+            <a:endParaRPr lang="en-US" sz="2200" dirty="0"/>
+          </a:p>
+        </p:txBody>
+      </p:sp>
+      <p:sp>
+        <p:nvSpPr>
+          <p:cNvPr id="6" name="Shape 4"/>
+          <p:cNvSpPr/>
+          <p:nvPr/>
+        </p:nvSpPr>
+        <p:spPr>
+          <a:xfrm>
+            <a:off x="457200" y="1143000"/>
+            <a:ext cx="11277295" cy="3756914"/>
+          </a:xfrm>
+          <a:prstGeom prst="roundRect">
+            <a:avLst>
+              <a:gd name="adj" fmla="val 1947"/>
+            </a:avLst>
+          </a:prstGeom>
+          <a:solidFill>
+            <a:srgbClr val="FFFFFF"/>
+          </a:solidFill>
+          <a:ln w="9525">
+            <a:solidFill>
+              <a:srgbClr val="C8E6DF"/>
+            </a:solidFill>
+            <a:prstDash val="solid"/>
+          </a:ln>
+        </p:spPr>
+      </p:sp>
+      <p:graphicFrame>
+        <p:nvGraphicFramePr>
+          <p:cNvPr id="28" name="Table 0"/>
+          <p:cNvGraphicFramePr>
+            <a:graphicFrameLocks noGrp="1"/>
+          </p:cNvGraphicFramePr>
+          <p:nvPr>
+            <p:extLst>
+              <p:ext uri="{D42A27DB-BD31-4B8C-83A1-F6EECF244321}">
+                <p14:modId xmlns:p14="http://schemas.microsoft.com/office/powerpoint/2010/main" val="1579011935"/>
+              </p:ext>
+            </p:extLst>
+          </p:nvPr>
+        </p:nvGraphicFramePr>
+        <p:xfrm>
+          <a:off x="685800" y="1325880"/>
+          <a:ext cx="10820095" cy="914400"/>
+        </p:xfrm>
+        <a:graphic>
+          <a:graphicData uri="http://schemas.openxmlformats.org/drawingml/2006/table">
+            <a:tbl>
+              <a:tblPr/>
+              <a:tblGrid>
+                <a:gridCol w="5410048"/>
+                <a:gridCol w="5410048"/>
+              </a:tblGrid>
+              <a:tr h="320040">
+                <a:tc>
+                  <a:txBody>
+                    <a:bodyPr/>
+                    <a:lstStyle/>
+                    <a:p>
+                      <a:pPr indent="0" marL="0">
+                        <a:buNone/>
+                      </a:pPr>
+                      <a:r>
+                        <a:rPr lang="en-US" sz="1100" b="1" dirty="0">
+                          <a:solidFill>
+                            <a:srgbClr val="FFFFFF"/>
+                          </a:solidFill>
+                          <a:latin typeface="Malgun Gothic" pitchFamily="34" charset="0"/>
+                          <a:ea typeface="Malgun Gothic" pitchFamily="34" charset="-122"/>
+                          <a:cs typeface="Malgun Gothic" pitchFamily="34" charset="-120"/>
+                        </a:rPr>
+                        <a:t>항목</a:t>
+                      </a:r>
+                      <a:endParaRPr lang="en-US" sz="1100" dirty="0">
+                        <a:latin typeface="Malgun Gothic" charset="0"/>
+                        <a:ea typeface="Malgun Gothic" charset="0"/>
+                        <a:cs typeface="Malgun Gothic" charset="0"/>
+                      </a:endParaRPr>
+                    </a:p>
+                  </a:txBody>
+                  <a:tcPr marL="91440" marR="91440" marT="45720" marB="45720">
+                    <a:lnL w="12700" cap="flat" cmpd="sng" algn="ctr">
+                      <a:solidFill>
+                        <a:srgbClr val="C8E6DF"/>
+                      </a:solidFill>
+                      <a:prstDash val="solid"/>
+                      <a:round/>
+                      <a:headEnd type="none" w="med" len="med"/>
+                      <a:tailEnd type="none" w="med" len="med"/>
+                    </a:lnL>
+                    <a:lnR w="12700" cap="flat" cmpd="sng" algn="ctr">
+                      <a:solidFill>
+                        <a:srgbClr val="C8E6DF"/>
+                      </a:solidFill>
+                      <a:prstDash val="solid"/>
+                      <a:round/>
+                      <a:headEnd type="none" w="med" len="med"/>
+                      <a:tailEnd type="none" w="med" len="med"/>
+                    </a:lnR>
+                    <a:lnT w="12700" cap="flat" cmpd="sng" algn="ctr">
+                      <a:solidFill>
+                        <a:srgbClr val="C8E6DF"/>
+                      </a:solidFill>
+                      <a:prstDash val="solid"/>
+                      <a:round/>
+                      <a:headEnd type="none" w="med" len="med"/>
+                      <a:tailEnd type="none" w="med" len="med"/>
+                    </a:lnT>
+                    <a:lnB w="12700" cap="flat" cmpd="sng" algn="ctr">
+                      <a:solidFill>
+                        <a:srgbClr val="C8E6DF"/>
+                      </a:solidFill>
+                      <a:prstDash val="solid"/>
+                      <a:round/>
+                      <a:headEnd type="none" w="med" len="med"/>
+                      <a:tailEnd type="none" w="med" len="med"/>
+                    </a:lnB>
+                    <a:solidFill>
+                      <a:srgbClr val="10A37F"/>
+                    </a:solidFill>
+                  </a:tcPr>
+                </a:tc>
+                <a:tc>
+                  <a:txBody>
+                    <a:bodyPr/>
+                    <a:lstStyle/>
+                    <a:p>
+                      <a:pPr indent="0" marL="0">
+                        <a:buNone/>
+                      </a:pPr>
+                      <a:r>
+                        <a:rPr lang="en-US" sz="1100" b="1" dirty="0">
+                          <a:solidFill>
+                            <a:srgbClr val="FFFFFF"/>
+                          </a:solidFill>
+                          <a:latin typeface="Malgun Gothic" pitchFamily="34" charset="0"/>
+                          <a:ea typeface="Malgun Gothic" pitchFamily="34" charset="-122"/>
+                          <a:cs typeface="Malgun Gothic" pitchFamily="34" charset="-120"/>
+                        </a:rPr>
+                        <a:t>내용</a:t>
+                      </a:r>
+                      <a:endParaRPr lang="en-US" sz="1100" dirty="0">
+                        <a:latin typeface="Malgun Gothic" charset="0"/>
+                        <a:ea typeface="Malgun Gothic" charset="0"/>
+                        <a:cs typeface="Malgun Gothic" charset="0"/>
+                      </a:endParaRPr>
+                    </a:p>
+                  </a:txBody>
+                  <a:tcPr marL="91440" marR="91440" marT="45720" marB="45720">
+                    <a:lnL w="12700" cap="flat" cmpd="sng" algn="ctr">
+                      <a:solidFill>
+                        <a:srgbClr val="C8E6DF"/>
+                      </a:solidFill>
+                      <a:prstDash val="solid"/>
+                      <a:round/>
+                      <a:headEnd type="none" w="med" len="med"/>
+                      <a:tailEnd type="none" w="med" len="med"/>
+                    </a:lnL>
+                    <a:lnR w="12700" cap="flat" cmpd="sng" algn="ctr">
+                      <a:solidFill>
+                        <a:srgbClr val="C8E6DF"/>
+                      </a:solidFill>
+                      <a:prstDash val="solid"/>
+                      <a:round/>
+                      <a:headEnd type="none" w="med" len="med"/>
+                      <a:tailEnd type="none" w="med" len="med"/>
+                    </a:lnR>
+                    <a:lnT w="12700" cap="flat" cmpd="sng" algn="ctr">
+                      <a:solidFill>
+                        <a:srgbClr val="C8E6DF"/>
+                      </a:solidFill>
+                      <a:prstDash val="solid"/>
+                      <a:round/>
+                      <a:headEnd type="none" w="med" len="med"/>
+                      <a:tailEnd type="none" w="med" len="med"/>
+                    </a:lnT>
+                    <a:lnB w="12700" cap="flat" cmpd="sng" algn="ctr">
+                      <a:solidFill>
+                        <a:srgbClr val="C8E6DF"/>
+                      </a:solidFill>
+                      <a:prstDash val="solid"/>
+                      <a:round/>
+                      <a:headEnd type="none" w="med" len="med"/>
+                      <a:tailEnd type="none" w="med" len="med"/>
+                    </a:lnB>
+                    <a:solidFill>
+                      <a:srgbClr val="10A37F"/>
+                    </a:solidFill>
+                  </a:tcPr>
+                </a:tc>
+              </a:tr>
+              <a:tr h="256032">
+                <a:tc>
+                  <a:txBody>
+                    <a:bodyPr/>
+                    <a:lstStyle/>
+                    <a:p>
+                      <a:pPr indent="0" marL="0">
+                        <a:buNone/>
+                      </a:pPr>
+                      <a:r>
+                        <a:rPr lang="en-US" sz="1000" dirty="0">
+                          <a:solidFill>
+                            <a:srgbClr val="475569"/>
+                          </a:solidFill>
+                          <a:latin typeface="Malgun Gothic" pitchFamily="34" charset="0"/>
+                          <a:ea typeface="Malgun Gothic" pitchFamily="34" charset="-122"/>
+                          <a:cs typeface="Malgun Gothic" pitchFamily="34" charset="-120"/>
+                        </a:rPr>
+                        <a:t>숏코드 명</a:t>
+                      </a:r>
+                      <a:endParaRPr lang="en-US" sz="1000" dirty="0">
+                        <a:latin typeface="Malgun Gothic" charset="0"/>
+                        <a:ea typeface="Malgun Gothic" charset="0"/>
+                        <a:cs typeface="Malgun Gothic" charset="0"/>
+                      </a:endParaRPr>
+                    </a:p>
+                  </a:txBody>
+                  <a:tcPr marL="91440" marR="91440" marT="45720" marB="45720">
+                    <a:lnL w="12700" cap="flat" cmpd="sng" algn="ctr">
+                      <a:solidFill>
+                        <a:srgbClr val="C8E6DF"/>
+                      </a:solidFill>
+                      <a:prstDash val="solid"/>
+                      <a:round/>
+                      <a:headEnd type="none" w="med" len="med"/>
+                      <a:tailEnd type="none" w="med" len="med"/>
+                    </a:lnL>
+                    <a:lnR w="12700" cap="flat" cmpd="sng" algn="ctr">
+                      <a:solidFill>
+                        <a:srgbClr val="C8E6DF"/>
+                      </a:solidFill>
+                      <a:prstDash val="solid"/>
+                      <a:round/>
+                      <a:headEnd type="none" w="med" len="med"/>
+                      <a:tailEnd type="none" w="med" len="med"/>
+                    </a:lnR>
+                    <a:lnT w="12700" cap="flat" cmpd="sng" algn="ctr">
+                      <a:solidFill>
+                        <a:srgbClr val="C8E6DF"/>
+                      </a:solidFill>
+                      <a:prstDash val="solid"/>
+                      <a:round/>
+                      <a:headEnd type="none" w="med" len="med"/>
+                      <a:tailEnd type="none" w="med" len="med"/>
+                    </a:lnT>
+                    <a:lnB w="12700" cap="flat" cmpd="sng" algn="ctr">
+                      <a:solidFill>
+                        <a:srgbClr val="C8E6DF"/>
+                      </a:solidFill>
+                      <a:prstDash val="solid"/>
+                      <a:round/>
+                      <a:headEnd type="none" w="med" len="med"/>
+                      <a:tailEnd type="none" w="med" len="med"/>
+                    </a:lnB>
+                  </a:tcPr>
+                </a:tc>
+                <a:tc>
+                  <a:txBody>
+                    <a:bodyPr/>
+                    <a:lstStyle/>
+                    <a:p>
+                      <a:pPr indent="0" marL="0">
+                        <a:buNone/>
+                      </a:pPr>
+                      <a:r>
+                        <a:rPr lang="en-US" sz="1000" dirty="0">
+                          <a:solidFill>
+                            <a:srgbClr val="475569"/>
+                          </a:solidFill>
+                          <a:latin typeface="Malgun Gothic" pitchFamily="34" charset="0"/>
+                          <a:ea typeface="Malgun Gothic" pitchFamily="34" charset="-122"/>
+                          <a:cs typeface="Malgun Gothic" pitchFamily="34" charset="-120"/>
+                        </a:rPr>
+                        <a:t>summary-bar</a:t>
+                      </a:r>
+                      <a:endParaRPr lang="en-US" sz="1000" dirty="0">
+                        <a:latin typeface="Malgun Gothic" charset="0"/>
+                        <a:ea typeface="Malgun Gothic" charset="0"/>
+                        <a:cs typeface="Malgun Gothic" charset="0"/>
+                      </a:endParaRPr>
+                    </a:p>
+                  </a:txBody>
+                  <a:tcPr marL="91440" marR="91440" marT="45720" marB="45720">
+                    <a:lnL w="12700" cap="flat" cmpd="sng" algn="ctr">
+                      <a:solidFill>
+                        <a:srgbClr val="C8E6DF"/>
+                      </a:solidFill>
+                      <a:prstDash val="solid"/>
+                      <a:round/>
+                      <a:headEnd type="none" w="med" len="med"/>
+                      <a:tailEnd type="none" w="med" len="med"/>
+                    </a:lnL>
+                    <a:lnR w="12700" cap="flat" cmpd="sng" algn="ctr">
+                      <a:solidFill>
+                        <a:srgbClr val="C8E6DF"/>
+                      </a:solidFill>
+                      <a:prstDash val="solid"/>
+                      <a:round/>
+                      <a:headEnd type="none" w="med" len="med"/>
+                      <a:tailEnd type="none" w="med" len="med"/>
+                    </a:lnR>
+                    <a:lnT w="12700" cap="flat" cmpd="sng" algn="ctr">
+                      <a:solidFill>
+                        <a:srgbClr val="C8E6DF"/>
+                      </a:solidFill>
+                      <a:prstDash val="solid"/>
+                      <a:round/>
+                      <a:headEnd type="none" w="med" len="med"/>
+                      <a:tailEnd type="none" w="med" len="med"/>
+                    </a:lnT>
+                    <a:lnB w="12700" cap="flat" cmpd="sng" algn="ctr">
+                      <a:solidFill>
+                        <a:srgbClr val="C8E6DF"/>
+                      </a:solidFill>
+                      <a:prstDash val="solid"/>
+                      <a:round/>
+                      <a:headEnd type="none" w="med" len="med"/>
+                      <a:tailEnd type="none" w="med" len="med"/>
+                    </a:lnB>
+                  </a:tcPr>
+                </a:tc>
+              </a:tr>
+              <a:tr h="256032">
+                <a:tc>
+                  <a:txBody>
+                    <a:bodyPr/>
+                    <a:lstStyle/>
+                    <a:p>
+                      <a:pPr indent="0" marL="0">
+                        <a:buNone/>
+                      </a:pPr>
+                      <a:r>
+                        <a:rPr lang="en-US" sz="1000" dirty="0">
+                          <a:solidFill>
+                            <a:srgbClr val="475569"/>
+                          </a:solidFill>
+                          <a:latin typeface="Malgun Gothic" pitchFamily="34" charset="0"/>
+                          <a:ea typeface="Malgun Gothic" pitchFamily="34" charset="-122"/>
+                          <a:cs typeface="Malgun Gothic" pitchFamily="34" charset="-120"/>
+                        </a:rPr>
+                        <a:t>구현내용</a:t>
+                      </a:r>
+                      <a:endParaRPr lang="en-US" sz="1000" dirty="0">
+                        <a:latin typeface="Malgun Gothic" charset="0"/>
+                        <a:ea typeface="Malgun Gothic" charset="0"/>
+                        <a:cs typeface="Malgun Gothic" charset="0"/>
+                      </a:endParaRPr>
+                    </a:p>
+                  </a:txBody>
+                  <a:tcPr marL="91440" marR="91440" marT="45720" marB="45720">
+                    <a:lnL w="12700" cap="flat" cmpd="sng" algn="ctr">
+                      <a:solidFill>
+                        <a:srgbClr val="C8E6DF"/>
+                      </a:solidFill>
+                      <a:prstDash val="solid"/>
+                      <a:round/>
+                      <a:headEnd type="none" w="med" len="med"/>
+                      <a:tailEnd type="none" w="med" len="med"/>
+                    </a:lnL>
+                    <a:lnR w="12700" cap="flat" cmpd="sng" algn="ctr">
+                      <a:solidFill>
+                        <a:srgbClr val="C8E6DF"/>
+                      </a:solidFill>
+                      <a:prstDash val="solid"/>
+                      <a:round/>
+                      <a:headEnd type="none" w="med" len="med"/>
+                      <a:tailEnd type="none" w="med" len="med"/>
+                    </a:lnR>
+                    <a:lnT w="12700" cap="flat" cmpd="sng" algn="ctr">
+                      <a:solidFill>
+                        <a:srgbClr val="C8E6DF"/>
+                      </a:solidFill>
+                      <a:prstDash val="solid"/>
+                      <a:round/>
+                      <a:headEnd type="none" w="med" len="med"/>
+                      <a:tailEnd type="none" w="med" len="med"/>
+                    </a:lnT>
+                    <a:lnB w="12700" cap="flat" cmpd="sng" algn="ctr">
+                      <a:solidFill>
+                        <a:srgbClr val="C8E6DF"/>
+                      </a:solidFill>
+                      <a:prstDash val="solid"/>
+                      <a:round/>
+                      <a:headEnd type="none" w="med" len="med"/>
+                      <a:tailEnd type="none" w="med" len="med"/>
+                    </a:lnB>
+                  </a:tcPr>
+                </a:tc>
+                <a:tc>
+                  <a:txBody>
+                    <a:bodyPr/>
+                    <a:lstStyle/>
+                    <a:p>
+                      <a:pPr indent="0" marL="0">
+                        <a:buNone/>
+                      </a:pPr>
+                      <a:r>
+                        <a:rPr lang="en-US" sz="1000" dirty="0">
+                          <a:solidFill>
+                            <a:srgbClr val="475569"/>
+                          </a:solidFill>
+                          <a:latin typeface="Malgun Gothic" pitchFamily="34" charset="0"/>
+                          <a:ea typeface="Malgun Gothic" pitchFamily="34" charset="-122"/>
+                          <a:cs typeface="Malgun Gothic" pitchFamily="34" charset="-120"/>
+                        </a:rPr>
+                        <a:t>숏코드 문서들의 통계, 주요 수치 등을 가로 격자 형태로 요약 노출해 주는 수치 뱃지 숏코드입니다.</a:t>
+                      </a:r>
+                      <a:endParaRPr lang="en-US" sz="1000" dirty="0">
+                        <a:latin typeface="Malgun Gothic" charset="0"/>
+                        <a:ea typeface="Malgun Gothic" charset="0"/>
+                        <a:cs typeface="Malgun Gothic" charset="0"/>
+                      </a:endParaRPr>
+                    </a:p>
+                  </a:txBody>
+                  <a:tcPr marL="91440" marR="91440" marT="45720" marB="45720">
+                    <a:lnL w="12700" cap="flat" cmpd="sng" algn="ctr">
+                      <a:solidFill>
+                        <a:srgbClr val="C8E6DF"/>
+                      </a:solidFill>
+                      <a:prstDash val="solid"/>
+                      <a:round/>
+                      <a:headEnd type="none" w="med" len="med"/>
+                      <a:tailEnd type="none" w="med" len="med"/>
+                    </a:lnL>
+                    <a:lnR w="12700" cap="flat" cmpd="sng" algn="ctr">
+                      <a:solidFill>
+                        <a:srgbClr val="C8E6DF"/>
+                      </a:solidFill>
+                      <a:prstDash val="solid"/>
+                      <a:round/>
+                      <a:headEnd type="none" w="med" len="med"/>
+                      <a:tailEnd type="none" w="med" len="med"/>
+                    </a:lnR>
+                    <a:lnT w="12700" cap="flat" cmpd="sng" algn="ctr">
+                      <a:solidFill>
+                        <a:srgbClr val="C8E6DF"/>
+                      </a:solidFill>
+                      <a:prstDash val="solid"/>
+                      <a:round/>
+                      <a:headEnd type="none" w="med" len="med"/>
+                      <a:tailEnd type="none" w="med" len="med"/>
+                    </a:lnT>
+                    <a:lnB w="12700" cap="flat" cmpd="sng" algn="ctr">
+                      <a:solidFill>
+                        <a:srgbClr val="C8E6DF"/>
+                      </a:solidFill>
+                      <a:prstDash val="solid"/>
+                      <a:round/>
+                      <a:headEnd type="none" w="med" len="med"/>
+                      <a:tailEnd type="none" w="med" len="med"/>
+                    </a:lnB>
+                  </a:tcPr>
+                </a:tc>
+              </a:tr>
+            </a:tbl>
+          </a:graphicData>
+        </a:graphic>
+      </p:graphicFrame>
+      <p:sp>
+        <p:nvSpPr>
+          <p:cNvPr id="8" name="Text 5"/>
+          <p:cNvSpPr/>
+          <p:nvPr/>
+        </p:nvSpPr>
+        <p:spPr>
+          <a:xfrm>
+            <a:off x="685800" y="2295144"/>
+            <a:ext cx="10820095" cy="237490"/>
+          </a:xfrm>
+          <a:prstGeom prst="rect">
+            <a:avLst/>
+          </a:prstGeom>
+          <a:noFill/>
+          <a:ln/>
+        </p:spPr>
+        <p:txBody>
+          <a:bodyPr wrap="square" rtlCol="0" anchor="t"/>
+          <a:lstStyle/>
+          <a:p>
+            <a:pPr indent="0" marL="0">
+              <a:buNone/>
+            </a:pPr>
+            <a:r>
+              <a:rPr lang="en-US" sz="1100" dirty="0">
+                <a:solidFill>
+                  <a:srgbClr val="475569"/>
+                </a:solidFill>
+                <a:latin typeface="Malgun Gothic" pitchFamily="34" charset="0"/>
+                <a:ea typeface="Malgun Gothic" pitchFamily="34" charset="-122"/>
+                <a:cs typeface="Malgun Gothic" pitchFamily="34" charset="-120"/>
+              </a:rPr>
+              <a:t>숏코드 입력내용</a:t>
+            </a:r>
+            <a:endParaRPr lang="en-US" sz="1100" dirty="0"/>
+          </a:p>
+        </p:txBody>
+      </p:sp>
+      <p:sp>
+        <p:nvSpPr>
+          <p:cNvPr id="9" name="Shape 6"/>
+          <p:cNvSpPr/>
+          <p:nvPr/>
+        </p:nvSpPr>
+        <p:spPr>
+          <a:xfrm>
+            <a:off x="685800" y="2669794"/>
+            <a:ext cx="10820095" cy="1910080"/>
+          </a:xfrm>
+          <a:prstGeom prst="rect">
+            <a:avLst/>
+          </a:prstGeom>
+          <a:solidFill>
+            <a:srgbClr val="0F172A"/>
+          </a:solidFill>
+          <a:ln w="9525">
+            <a:solidFill>
+              <a:srgbClr val="C8E6DF"/>
+            </a:solidFill>
+            <a:prstDash val="solid"/>
+          </a:ln>
+        </p:spPr>
+      </p:sp>
+      <p:sp>
+        <p:nvSpPr>
+          <p:cNvPr id="10" name="Text 7"/>
+          <p:cNvSpPr/>
+          <p:nvPr/>
+        </p:nvSpPr>
+        <p:spPr>
+          <a:xfrm>
+            <a:off x="795528" y="2742946"/>
+            <a:ext cx="10600639" cy="1818640"/>
+          </a:xfrm>
+          <a:prstGeom prst="rect">
+            <a:avLst/>
+          </a:prstGeom>
+          <a:noFill/>
+          <a:ln/>
+        </p:spPr>
+        <p:txBody>
+          <a:bodyPr wrap="square" rtlCol="0" anchor="t"/>
+          <a:lstStyle/>
+          <a:p>
+            <a:pPr indent="0" marL="0">
+              <a:buNone/>
+            </a:pPr>
+            <a:r>
+              <a:rPr lang="en-US" sz="1000" dirty="0">
+                <a:solidFill>
+                  <a:srgbClr val="A8B2D8"/>
+                </a:solidFill>
+                <a:latin typeface="Consolas" pitchFamily="34" charset="0"/>
+                <a:ea typeface="Consolas" pitchFamily="34" charset="-122"/>
+                <a:cs typeface="Consolas" pitchFamily="34" charset="-120"/>
+              </a:rPr>
+              <a:t>\::: summary-bar</a:t>
+            </a:r>
+            <a:endParaRPr lang="en-US" sz="1000" dirty="0"/>
+          </a:p>
+          <a:p>
+            <a:pPr indent="0" marL="0">
+              <a:buNone/>
+            </a:pPr>
+            <a:r>
+              <a:rPr lang="en-US" sz="1000" dirty="0">
+                <a:solidFill>
+                  <a:srgbClr val="A8B2D8"/>
+                </a:solidFill>
+                <a:latin typeface="Consolas" pitchFamily="34" charset="0"/>
+                <a:ea typeface="Consolas" pitchFamily="34" charset="-122"/>
+                <a:cs typeface="Consolas" pitchFamily="34" charset="-120"/>
+              </a:rPr>
+              <a:t>- icon: "29장"</a:t>
+            </a:r>
+            <a:endParaRPr lang="en-US" sz="1000" dirty="0"/>
+          </a:p>
+          <a:p>
+            <a:pPr indent="0" marL="0">
+              <a:buNone/>
+            </a:pPr>
+            <a:r>
+              <a:rPr lang="en-US" sz="1000" dirty="0">
+                <a:solidFill>
+                  <a:srgbClr val="A8B2D8"/>
+                </a:solidFill>
+                <a:latin typeface="Consolas" pitchFamily="34" charset="0"/>
+                <a:ea typeface="Consolas" pitchFamily="34" charset="-122"/>
+                <a:cs typeface="Consolas" pitchFamily="34" charset="-120"/>
+              </a:rPr>
+              <a:t>  title: "Total Chapters"</a:t>
+            </a:r>
+            <a:endParaRPr lang="en-US" sz="1000" dirty="0"/>
+          </a:p>
+          <a:p>
+            <a:pPr indent="0" marL="0">
+              <a:buNone/>
+            </a:pPr>
+            <a:r>
+              <a:rPr lang="en-US" sz="1000" dirty="0">
+                <a:solidFill>
+                  <a:srgbClr val="A8B2D8"/>
+                </a:solidFill>
+                <a:latin typeface="Consolas" pitchFamily="34" charset="0"/>
+                <a:ea typeface="Consolas" pitchFamily="34" charset="-122"/>
+                <a:cs typeface="Consolas" pitchFamily="34" charset="-120"/>
+              </a:rPr>
+              <a:t>- icon: "8부"</a:t>
+            </a:r>
+            <a:endParaRPr lang="en-US" sz="1000" dirty="0"/>
+          </a:p>
+          <a:p>
+            <a:pPr indent="0" marL="0">
+              <a:buNone/>
+            </a:pPr>
+            <a:r>
+              <a:rPr lang="en-US" sz="1000" dirty="0">
+                <a:solidFill>
+                  <a:srgbClr val="A8B2D8"/>
+                </a:solidFill>
+                <a:latin typeface="Consolas" pitchFamily="34" charset="0"/>
+                <a:ea typeface="Consolas" pitchFamily="34" charset="-122"/>
+                <a:cs typeface="Consolas" pitchFamily="34" charset="-120"/>
+              </a:rPr>
+              <a:t>  title: "Parts"</a:t>
+            </a:r>
+            <a:endParaRPr lang="en-US" sz="1000" dirty="0"/>
+          </a:p>
+          <a:p>
+            <a:pPr indent="0" marL="0">
+              <a:buNone/>
+            </a:pPr>
+            <a:r>
+              <a:rPr lang="en-US" sz="1000" dirty="0">
+                <a:solidFill>
+                  <a:srgbClr val="A8B2D8"/>
+                </a:solidFill>
+                <a:latin typeface="Consolas" pitchFamily="34" charset="0"/>
+                <a:ea typeface="Consolas" pitchFamily="34" charset="-122"/>
+                <a:cs typeface="Consolas" pitchFamily="34" charset="-120"/>
+              </a:rPr>
+              <a:t>- icon: "24종"</a:t>
+            </a:r>
+            <a:endParaRPr lang="en-US" sz="1000" dirty="0"/>
+          </a:p>
+          <a:p>
+            <a:pPr indent="0" marL="0">
+              <a:buNone/>
+            </a:pPr>
+            <a:r>
+              <a:rPr lang="en-US" sz="1000" dirty="0">
+                <a:solidFill>
+                  <a:srgbClr val="A8B2D8"/>
+                </a:solidFill>
+                <a:latin typeface="Consolas" pitchFamily="34" charset="0"/>
+                <a:ea typeface="Consolas" pitchFamily="34" charset="-122"/>
+                <a:cs typeface="Consolas" pitchFamily="34" charset="-120"/>
+              </a:rPr>
+              <a:t>  title: "Support Shortcodes"</a:t>
+            </a:r>
+            <a:endParaRPr lang="en-US" sz="1000" dirty="0"/>
+          </a:p>
+          <a:p>
+            <a:pPr indent="0" marL="0">
+              <a:buNone/>
+            </a:pPr>
+            <a:r>
+              <a:rPr lang="en-US" sz="1000" dirty="0">
+                <a:solidFill>
+                  <a:srgbClr val="A8B2D8"/>
+                </a:solidFill>
+                <a:latin typeface="Consolas" pitchFamily="34" charset="0"/>
+                <a:ea typeface="Consolas" pitchFamily="34" charset="-122"/>
+                <a:cs typeface="Consolas" pitchFamily="34" charset="-120"/>
+              </a:rPr>
+              <a:t>\:::</a:t>
+            </a:r>
+            <a:endParaRPr lang="en-US" sz="1000" dirty="0"/>
           </a:p>
         </p:txBody>
       </p:sp>

</xml_diff>

<commit_message>
fix(parser): resolve literal backslash n and custom bullet rendering bugs
</commit_message>
<xml_diff>
--- a/public/showcase/showcase.pptx
+++ b/public/showcase/showcase.pptx
@@ -40513,7 +40513,41 @@
                 <a:ea typeface="Malgun Gothic" pitchFamily="34" charset="-122"/>
                 <a:cs typeface="Malgun Gothic" pitchFamily="34" charset="-120"/>
               </a:rPr>
-              <a:t>대용량 파일도 빠르게 처리\n병렬 처리 지원\n메모리 최적화</a:t>
+              <a:t>대용량 파일도 빠르게 처리</a:t>
+            </a:r>
+            <a:endParaRPr lang="en-US" sz="1000" dirty="0"/>
+          </a:p>
+          <a:p>
+            <a:pPr indent="0" marL="0">
+              <a:buNone/>
+            </a:pPr>
+            <a:r>
+              <a:rPr lang="en-US" sz="1000" dirty="0">
+                <a:solidFill>
+                  <a:srgbClr val="475569"/>
+                </a:solidFill>
+                <a:latin typeface="Malgun Gothic" pitchFamily="34" charset="0"/>
+                <a:ea typeface="Malgun Gothic" pitchFamily="34" charset="-122"/>
+                <a:cs typeface="Malgun Gothic" pitchFamily="34" charset="-120"/>
+              </a:rPr>
+              <a:t>병렬 처리 지원</a:t>
+            </a:r>
+            <a:endParaRPr lang="en-US" sz="1000" dirty="0"/>
+          </a:p>
+          <a:p>
+            <a:pPr indent="0" marL="0">
+              <a:buNone/>
+            </a:pPr>
+            <a:r>
+              <a:rPr lang="en-US" sz="1000" dirty="0">
+                <a:solidFill>
+                  <a:srgbClr val="475569"/>
+                </a:solidFill>
+                <a:latin typeface="Malgun Gothic" pitchFamily="34" charset="0"/>
+                <a:ea typeface="Malgun Gothic" pitchFamily="34" charset="-122"/>
+                <a:cs typeface="Malgun Gothic" pitchFamily="34" charset="-120"/>
+              </a:rPr>
+              <a:t>메모리 최적화</a:t>
             </a:r>
             <a:endParaRPr lang="en-US" sz="1000" dirty="0"/>
           </a:p>
@@ -40684,7 +40718,41 @@
                 <a:ea typeface="Malgun Gothic" pitchFamily="34" charset="-122"/>
                 <a:cs typeface="Malgun Gothic" pitchFamily="34" charset="-120"/>
               </a:rPr>
-              <a:t>엔드투엔드 암호화\n접근 권한 관리\n감사 로그 제공</a:t>
+              <a:t>엔드투엔드 암호화</a:t>
+            </a:r>
+            <a:endParaRPr lang="en-US" sz="1000" dirty="0"/>
+          </a:p>
+          <a:p>
+            <a:pPr indent="0" marL="0">
+              <a:buNone/>
+            </a:pPr>
+            <a:r>
+              <a:rPr lang="en-US" sz="1000" dirty="0">
+                <a:solidFill>
+                  <a:srgbClr val="475569"/>
+                </a:solidFill>
+                <a:latin typeface="Malgun Gothic" pitchFamily="34" charset="0"/>
+                <a:ea typeface="Malgun Gothic" pitchFamily="34" charset="-122"/>
+                <a:cs typeface="Malgun Gothic" pitchFamily="34" charset="-120"/>
+              </a:rPr>
+              <a:t>접근 권한 관리</a:t>
+            </a:r>
+            <a:endParaRPr lang="en-US" sz="1000" dirty="0"/>
+          </a:p>
+          <a:p>
+            <a:pPr indent="0" marL="0">
+              <a:buNone/>
+            </a:pPr>
+            <a:r>
+              <a:rPr lang="en-US" sz="1000" dirty="0">
+                <a:solidFill>
+                  <a:srgbClr val="475569"/>
+                </a:solidFill>
+                <a:latin typeface="Malgun Gothic" pitchFamily="34" charset="0"/>
+                <a:ea typeface="Malgun Gothic" pitchFamily="34" charset="-122"/>
+                <a:cs typeface="Malgun Gothic" pitchFamily="34" charset="-120"/>
+              </a:rPr>
+              <a:t>감사 로그 제공</a:t>
             </a:r>
             <a:endParaRPr lang="en-US" sz="1000" dirty="0"/>
           </a:p>
@@ -41326,7 +41394,41 @@
                 <a:ea typeface="Malgun Gothic" pitchFamily="34" charset="-122"/>
                 <a:cs typeface="Malgun Gothic" pitchFamily="34" charset="-120"/>
               </a:rPr>
-              <a:t>자동 생성\n버전 관리\n다국어 지원</a:t>
+              <a:t>자동 생성</a:t>
+            </a:r>
+            <a:endParaRPr lang="en-US" sz="1000" dirty="0"/>
+          </a:p>
+          <a:p>
+            <a:pPr algn="ctr" indent="0" marL="0">
+              <a:buNone/>
+            </a:pPr>
+            <a:r>
+              <a:rPr lang="en-US" sz="1000" dirty="0">
+                <a:solidFill>
+                  <a:srgbClr val="475569"/>
+                </a:solidFill>
+                <a:latin typeface="Malgun Gothic" pitchFamily="34" charset="0"/>
+                <a:ea typeface="Malgun Gothic" pitchFamily="34" charset="-122"/>
+                <a:cs typeface="Malgun Gothic" pitchFamily="34" charset="-120"/>
+              </a:rPr>
+              <a:t>버전 관리</a:t>
+            </a:r>
+            <a:endParaRPr lang="en-US" sz="1000" dirty="0"/>
+          </a:p>
+          <a:p>
+            <a:pPr algn="ctr" indent="0" marL="0">
+              <a:buNone/>
+            </a:pPr>
+            <a:r>
+              <a:rPr lang="en-US" sz="1000" dirty="0">
+                <a:solidFill>
+                  <a:srgbClr val="475569"/>
+                </a:solidFill>
+                <a:latin typeface="Malgun Gothic" pitchFamily="34" charset="0"/>
+                <a:ea typeface="Malgun Gothic" pitchFamily="34" charset="-122"/>
+                <a:cs typeface="Malgun Gothic" pitchFamily="34" charset="-120"/>
+              </a:rPr>
+              <a:t>다국어 지원</a:t>
             </a:r>
             <a:endParaRPr lang="en-US" sz="1000" dirty="0"/>
           </a:p>
@@ -41467,7 +41569,41 @@
                 <a:ea typeface="Malgun Gothic" pitchFamily="34" charset="-122"/>
                 <a:cs typeface="Malgun Gothic" pitchFamily="34" charset="-120"/>
               </a:rPr>
-              <a:t>CI/CD 통합\n테스트 자동화\n배포 스크립트</a:t>
+              <a:t>CI/CD 통합</a:t>
+            </a:r>
+            <a:endParaRPr lang="en-US" sz="1000" dirty="0"/>
+          </a:p>
+          <a:p>
+            <a:pPr algn="ctr" indent="0" marL="0">
+              <a:buNone/>
+            </a:pPr>
+            <a:r>
+              <a:rPr lang="en-US" sz="1000" dirty="0">
+                <a:solidFill>
+                  <a:srgbClr val="475569"/>
+                </a:solidFill>
+                <a:latin typeface="Malgun Gothic" pitchFamily="34" charset="0"/>
+                <a:ea typeface="Malgun Gothic" pitchFamily="34" charset="-122"/>
+                <a:cs typeface="Malgun Gothic" pitchFamily="34" charset="-120"/>
+              </a:rPr>
+              <a:t>테스트 자동화</a:t>
+            </a:r>
+            <a:endParaRPr lang="en-US" sz="1000" dirty="0"/>
+          </a:p>
+          <a:p>
+            <a:pPr algn="ctr" indent="0" marL="0">
+              <a:buNone/>
+            </a:pPr>
+            <a:r>
+              <a:rPr lang="en-US" sz="1000" dirty="0">
+                <a:solidFill>
+                  <a:srgbClr val="475569"/>
+                </a:solidFill>
+                <a:latin typeface="Malgun Gothic" pitchFamily="34" charset="0"/>
+                <a:ea typeface="Malgun Gothic" pitchFamily="34" charset="-122"/>
+                <a:cs typeface="Malgun Gothic" pitchFamily="34" charset="-120"/>
+              </a:rPr>
+              <a:t>배포 스크립트</a:t>
             </a:r>
             <a:endParaRPr lang="en-US" sz="1000" dirty="0"/>
           </a:p>
@@ -41608,7 +41744,41 @@
                 <a:ea typeface="Malgun Gothic" pitchFamily="34" charset="-122"/>
                 <a:cs typeface="Malgun Gothic" pitchFamily="34" charset="-120"/>
               </a:rPr>
-              <a:t>실시간 모니터링\n대시보드\n알림 설정</a:t>
+              <a:t>실시간 모니터링</a:t>
+            </a:r>
+            <a:endParaRPr lang="en-US" sz="1000" dirty="0"/>
+          </a:p>
+          <a:p>
+            <a:pPr algn="ctr" indent="0" marL="0">
+              <a:buNone/>
+            </a:pPr>
+            <a:r>
+              <a:rPr lang="en-US" sz="1000" dirty="0">
+                <a:solidFill>
+                  <a:srgbClr val="475569"/>
+                </a:solidFill>
+                <a:latin typeface="Malgun Gothic" pitchFamily="34" charset="0"/>
+                <a:ea typeface="Malgun Gothic" pitchFamily="34" charset="-122"/>
+                <a:cs typeface="Malgun Gothic" pitchFamily="34" charset="-120"/>
+              </a:rPr>
+              <a:t>대시보드</a:t>
+            </a:r>
+            <a:endParaRPr lang="en-US" sz="1000" dirty="0"/>
+          </a:p>
+          <a:p>
+            <a:pPr algn="ctr" indent="0" marL="0">
+              <a:buNone/>
+            </a:pPr>
+            <a:r>
+              <a:rPr lang="en-US" sz="1000" dirty="0">
+                <a:solidFill>
+                  <a:srgbClr val="475569"/>
+                </a:solidFill>
+                <a:latin typeface="Malgun Gothic" pitchFamily="34" charset="0"/>
+                <a:ea typeface="Malgun Gothic" pitchFamily="34" charset="-122"/>
+                <a:cs typeface="Malgun Gothic" pitchFamily="34" charset="-120"/>
+              </a:rPr>
+              <a:t>알림 설정</a:t>
             </a:r>
             <a:endParaRPr lang="en-US" sz="1000" dirty="0"/>
           </a:p>
@@ -42222,7 +42392,41 @@
                 <a:ea typeface="Malgun Gothic" pitchFamily="34" charset="-122"/>
                 <a:cs typeface="Malgun Gothic" pitchFamily="34" charset="-120"/>
               </a:rPr>
-              <a:t>원클릭 배포\n자동 롤백\n무중단 업데이트</a:t>
+              <a:t>원클릭 배포</a:t>
+            </a:r>
+            <a:endParaRPr lang="en-US" sz="1000" dirty="0"/>
+          </a:p>
+          <a:p>
+            <a:pPr indent="0" marL="0">
+              <a:buNone/>
+            </a:pPr>
+            <a:r>
+              <a:rPr lang="en-US" sz="1000" dirty="0">
+                <a:solidFill>
+                  <a:srgbClr val="475569"/>
+                </a:solidFill>
+                <a:latin typeface="Malgun Gothic" pitchFamily="34" charset="0"/>
+                <a:ea typeface="Malgun Gothic" pitchFamily="34" charset="-122"/>
+                <a:cs typeface="Malgun Gothic" pitchFamily="34" charset="-120"/>
+              </a:rPr>
+              <a:t>자동 롤백</a:t>
+            </a:r>
+            <a:endParaRPr lang="en-US" sz="1000" dirty="0"/>
+          </a:p>
+          <a:p>
+            <a:pPr indent="0" marL="0">
+              <a:buNone/>
+            </a:pPr>
+            <a:r>
+              <a:rPr lang="en-US" sz="1000" dirty="0">
+                <a:solidFill>
+                  <a:srgbClr val="475569"/>
+                </a:solidFill>
+                <a:latin typeface="Malgun Gothic" pitchFamily="34" charset="0"/>
+                <a:ea typeface="Malgun Gothic" pitchFamily="34" charset="-122"/>
+                <a:cs typeface="Malgun Gothic" pitchFamily="34" charset="-120"/>
+              </a:rPr>
+              <a:t>무중단 업데이트</a:t>
             </a:r>
             <a:endParaRPr lang="en-US" sz="1000" dirty="0"/>
           </a:p>
@@ -42352,7 +42556,41 @@
                 <a:ea typeface="Malgun Gothic" pitchFamily="34" charset="-122"/>
                 <a:cs typeface="Malgun Gothic" pitchFamily="34" charset="-120"/>
               </a:rPr>
-              <a:t>자동 인증서\n방화벽 내장\n취약점 스캔</a:t>
+              <a:t>자동 인증서</a:t>
+            </a:r>
+            <a:endParaRPr lang="en-US" sz="1000" dirty="0"/>
+          </a:p>
+          <a:p>
+            <a:pPr indent="0" marL="0">
+              <a:buNone/>
+            </a:pPr>
+            <a:r>
+              <a:rPr lang="en-US" sz="1000" dirty="0">
+                <a:solidFill>
+                  <a:srgbClr val="475569"/>
+                </a:solidFill>
+                <a:latin typeface="Malgun Gothic" pitchFamily="34" charset="0"/>
+                <a:ea typeface="Malgun Gothic" pitchFamily="34" charset="-122"/>
+                <a:cs typeface="Malgun Gothic" pitchFamily="34" charset="-120"/>
+              </a:rPr>
+              <a:t>방화벽 내장</a:t>
+            </a:r>
+            <a:endParaRPr lang="en-US" sz="1000" dirty="0"/>
+          </a:p>
+          <a:p>
+            <a:pPr indent="0" marL="0">
+              <a:buNone/>
+            </a:pPr>
+            <a:r>
+              <a:rPr lang="en-US" sz="1000" dirty="0">
+                <a:solidFill>
+                  <a:srgbClr val="475569"/>
+                </a:solidFill>
+                <a:latin typeface="Malgun Gothic" pitchFamily="34" charset="0"/>
+                <a:ea typeface="Malgun Gothic" pitchFamily="34" charset="-122"/>
+                <a:cs typeface="Malgun Gothic" pitchFamily="34" charset="-120"/>
+              </a:rPr>
+              <a:t>취약점 스캔</a:t>
             </a:r>
             <a:endParaRPr lang="en-US" sz="1000" dirty="0"/>
           </a:p>

</xml_diff>